<commit_message>
docs(deck): simplify slide content for clearer presentation and self-reading
</commit_message>
<xml_diff>
--- a/docs/deck/Landshield-Deck.pptx
+++ b/docs/deck/Landshield-Deck.pptx
@@ -255,7 +255,7 @@
           <a:bodyPr/>
           <a:lstStyle/>
           <a:p>
-            <a:fld id="{C823E295-28DF-4E71-9F53-D45207DE2860}" type="datetimeFigureOut">
+            <a:fld id="{18FE2997-B109-4CE4-AFB1-78F134803C95}" type="datetimeFigureOut">
               <a:rPr lang="en-US" smtClean="0"/>
               <a:t>5/20/2026</a:t>
             </a:fld>
@@ -307,7 +307,7 @@
           <a:bodyPr/>
           <a:lstStyle/>
           <a:p>
-            <a:fld id="{41970ED4-46CD-4B2B-B2B3-745DA35D2A58}" type="slidenum">
+            <a:fld id="{6B5A31E5-CCDF-45E1-B52C-D30857F2ECD5}" type="slidenum">
               <a:rPr lang="en-US" smtClean="0"/>
               <a:t>‹#›</a:t>
             </a:fld>
@@ -349,7 +349,7 @@
     </p:spTree>
     <p:extLst>
       <p:ext uri="{BB962C8B-B14F-4D97-AF65-F5344CB8AC3E}">
-        <p14:creationId xmlns:p14="http://schemas.microsoft.com/office/powerpoint/2010/main" val="1155698506"/>
+        <p14:creationId xmlns:p14="http://schemas.microsoft.com/office/powerpoint/2010/main" val="2270718321"/>
       </p:ext>
     </p:extLst>
   </p:cSld>
@@ -466,7 +466,7 @@
           <a:bodyPr/>
           <a:lstStyle/>
           <a:p>
-            <a:fld id="{C823E295-28DF-4E71-9F53-D45207DE2860}" type="datetimeFigureOut">
+            <a:fld id="{18FE2997-B109-4CE4-AFB1-78F134803C95}" type="datetimeFigureOut">
               <a:rPr lang="en-US" smtClean="0"/>
               <a:t>5/20/2026</a:t>
             </a:fld>
@@ -508,7 +508,7 @@
           <a:bodyPr/>
           <a:lstStyle/>
           <a:p>
-            <a:fld id="{41970ED4-46CD-4B2B-B2B3-745DA35D2A58}" type="slidenum">
+            <a:fld id="{6B5A31E5-CCDF-45E1-B52C-D30857F2ECD5}" type="slidenum">
               <a:rPr lang="en-US" smtClean="0"/>
               <a:t>‹#›</a:t>
             </a:fld>
@@ -550,7 +550,7 @@
     </p:spTree>
     <p:extLst>
       <p:ext uri="{BB962C8B-B14F-4D97-AF65-F5344CB8AC3E}">
-        <p14:creationId xmlns:p14="http://schemas.microsoft.com/office/powerpoint/2010/main" val="1684051850"/>
+        <p14:creationId xmlns:p14="http://schemas.microsoft.com/office/powerpoint/2010/main" val="163759245"/>
       </p:ext>
     </p:extLst>
   </p:cSld>
@@ -681,7 +681,7 @@
           <a:bodyPr/>
           <a:lstStyle/>
           <a:p>
-            <a:fld id="{C823E295-28DF-4E71-9F53-D45207DE2860}" type="datetimeFigureOut">
+            <a:fld id="{18FE2997-B109-4CE4-AFB1-78F134803C95}" type="datetimeFigureOut">
               <a:rPr lang="en-US" smtClean="0"/>
               <a:t>5/20/2026</a:t>
             </a:fld>
@@ -723,7 +723,7 @@
           <a:bodyPr/>
           <a:lstStyle/>
           <a:p>
-            <a:fld id="{41970ED4-46CD-4B2B-B2B3-745DA35D2A58}" type="slidenum">
+            <a:fld id="{6B5A31E5-CCDF-45E1-B52C-D30857F2ECD5}" type="slidenum">
               <a:rPr lang="en-US" smtClean="0"/>
               <a:t>‹#›</a:t>
             </a:fld>
@@ -765,7 +765,7 @@
     </p:spTree>
     <p:extLst>
       <p:ext uri="{BB962C8B-B14F-4D97-AF65-F5344CB8AC3E}">
-        <p14:creationId xmlns:p14="http://schemas.microsoft.com/office/powerpoint/2010/main" val="4181230017"/>
+        <p14:creationId xmlns:p14="http://schemas.microsoft.com/office/powerpoint/2010/main" val="2188572846"/>
       </p:ext>
     </p:extLst>
   </p:cSld>
@@ -797,7 +797,7 @@
           <p:cNvPr id="2" name="Title 1">
             <a:extLst>
               <a:ext uri="{FF2B5EF4-FFF2-40B4-BE49-F238E27FC236}">
-                <a16:creationId xmlns:a16="http://schemas.microsoft.com/office/drawing/2014/main" id="{D646E1F5-79C2-1397-5AC3-9CA0DC2E35BF}"/>
+                <a16:creationId xmlns:a16="http://schemas.microsoft.com/office/drawing/2014/main" id="{15BEBC4C-E21F-D08F-A0C3-2763263447EF}"/>
               </a:ext>
             </a:extLst>
           </p:cNvPr>
@@ -825,7 +825,7 @@
           <p:cNvPr id="3" name="Text Placeholder 2">
             <a:extLst>
               <a:ext uri="{FF2B5EF4-FFF2-40B4-BE49-F238E27FC236}">
-                <a16:creationId xmlns:a16="http://schemas.microsoft.com/office/drawing/2014/main" id="{8DD004FB-1EC6-CCAB-5BA5-4E6DE2ED634C}"/>
+                <a16:creationId xmlns:a16="http://schemas.microsoft.com/office/drawing/2014/main" id="{5E286217-A709-1F9D-3776-D1A287124DC4}"/>
               </a:ext>
             </a:extLst>
           </p:cNvPr>
@@ -882,7 +882,7 @@
           <p:cNvPr id="4" name="Date Placeholder 3">
             <a:extLst>
               <a:ext uri="{FF2B5EF4-FFF2-40B4-BE49-F238E27FC236}">
-                <a16:creationId xmlns:a16="http://schemas.microsoft.com/office/drawing/2014/main" id="{695EF50D-7F40-AD55-33CB-22CCFD12872E}"/>
+                <a16:creationId xmlns:a16="http://schemas.microsoft.com/office/drawing/2014/main" id="{9B71CD7F-BBE9-2B64-6197-2B8CA5FC4C80}"/>
               </a:ext>
             </a:extLst>
           </p:cNvPr>
@@ -898,7 +898,7 @@
           <a:bodyPr/>
           <a:lstStyle/>
           <a:p>
-            <a:fld id="{C823E295-28DF-4E71-9F53-D45207DE2860}" type="datetimeFigureOut">
+            <a:fld id="{18FE2997-B109-4CE4-AFB1-78F134803C95}" type="datetimeFigureOut">
               <a:rPr lang="en-US" smtClean="0"/>
               <a:t>5/20/2026</a:t>
             </a:fld>
@@ -911,7 +911,7 @@
           <p:cNvPr id="5" name="Footer Placeholder 4">
             <a:extLst>
               <a:ext uri="{FF2B5EF4-FFF2-40B4-BE49-F238E27FC236}">
-                <a16:creationId xmlns:a16="http://schemas.microsoft.com/office/drawing/2014/main" id="{FA4BC1E9-62CB-4DC0-86AE-749DC3196E81}"/>
+                <a16:creationId xmlns:a16="http://schemas.microsoft.com/office/drawing/2014/main" id="{964E7AAD-3F30-EC84-F39D-4D32F080AC6C}"/>
               </a:ext>
             </a:extLst>
           </p:cNvPr>
@@ -936,7 +936,7 @@
           <p:cNvPr id="6" name="Slide Number Placeholder 5">
             <a:extLst>
               <a:ext uri="{FF2B5EF4-FFF2-40B4-BE49-F238E27FC236}">
-                <a16:creationId xmlns:a16="http://schemas.microsoft.com/office/drawing/2014/main" id="{9A5B9062-3D47-5E9D-549A-54AFC2E9C4E0}"/>
+                <a16:creationId xmlns:a16="http://schemas.microsoft.com/office/drawing/2014/main" id="{2F683B99-C521-C5CC-0E62-91FCE28EEAD4}"/>
               </a:ext>
             </a:extLst>
           </p:cNvPr>
@@ -952,7 +952,7 @@
           <a:bodyPr/>
           <a:lstStyle/>
           <a:p>
-            <a:fld id="{41970ED4-46CD-4B2B-B2B3-745DA35D2A58}" type="slidenum">
+            <a:fld id="{6B5A31E5-CCDF-45E1-B52C-D30857F2ECD5}" type="slidenum">
               <a:rPr lang="en-US" smtClean="0"/>
               <a:t>‹#›</a:t>
             </a:fld>
@@ -963,7 +963,7 @@
     </p:spTree>
     <p:extLst>
       <p:ext uri="{BB962C8B-B14F-4D97-AF65-F5344CB8AC3E}">
-        <p14:creationId xmlns:p14="http://schemas.microsoft.com/office/powerpoint/2010/main" val="1771616902"/>
+        <p14:creationId xmlns:p14="http://schemas.microsoft.com/office/powerpoint/2010/main" val="1480224987"/>
       </p:ext>
     </p:extLst>
   </p:cSld>
@@ -1080,7 +1080,7 @@
           <a:bodyPr/>
           <a:lstStyle/>
           <a:p>
-            <a:fld id="{C823E295-28DF-4E71-9F53-D45207DE2860}" type="datetimeFigureOut">
+            <a:fld id="{18FE2997-B109-4CE4-AFB1-78F134803C95}" type="datetimeFigureOut">
               <a:rPr lang="en-US" smtClean="0"/>
               <a:t>5/20/2026</a:t>
             </a:fld>
@@ -1122,7 +1122,7 @@
           <a:bodyPr/>
           <a:lstStyle/>
           <a:p>
-            <a:fld id="{41970ED4-46CD-4B2B-B2B3-745DA35D2A58}" type="slidenum">
+            <a:fld id="{6B5A31E5-CCDF-45E1-B52C-D30857F2ECD5}" type="slidenum">
               <a:rPr lang="en-US" smtClean="0"/>
               <a:t>‹#›</a:t>
             </a:fld>
@@ -1164,7 +1164,7 @@
     </p:spTree>
     <p:extLst>
       <p:ext uri="{BB962C8B-B14F-4D97-AF65-F5344CB8AC3E}">
-        <p14:creationId xmlns:p14="http://schemas.microsoft.com/office/powerpoint/2010/main" val="652335682"/>
+        <p14:creationId xmlns:p14="http://schemas.microsoft.com/office/powerpoint/2010/main" val="786959177"/>
       </p:ext>
     </p:extLst>
   </p:cSld>
@@ -1359,7 +1359,7 @@
           <a:bodyPr/>
           <a:lstStyle/>
           <a:p>
-            <a:fld id="{C823E295-28DF-4E71-9F53-D45207DE2860}" type="datetimeFigureOut">
+            <a:fld id="{18FE2997-B109-4CE4-AFB1-78F134803C95}" type="datetimeFigureOut">
               <a:rPr lang="en-US" smtClean="0"/>
               <a:t>5/20/2026</a:t>
             </a:fld>
@@ -1401,7 +1401,7 @@
           <a:bodyPr/>
           <a:lstStyle/>
           <a:p>
-            <a:fld id="{41970ED4-46CD-4B2B-B2B3-745DA35D2A58}" type="slidenum">
+            <a:fld id="{6B5A31E5-CCDF-45E1-B52C-D30857F2ECD5}" type="slidenum">
               <a:rPr lang="en-US" smtClean="0"/>
               <a:t>‹#›</a:t>
             </a:fld>
@@ -1443,7 +1443,7 @@
     </p:spTree>
     <p:extLst>
       <p:ext uri="{BB962C8B-B14F-4D97-AF65-F5344CB8AC3E}">
-        <p14:creationId xmlns:p14="http://schemas.microsoft.com/office/powerpoint/2010/main" val="4238145174"/>
+        <p14:creationId xmlns:p14="http://schemas.microsoft.com/office/powerpoint/2010/main" val="563974237"/>
       </p:ext>
     </p:extLst>
   </p:cSld>
@@ -1627,7 +1627,7 @@
           <a:bodyPr/>
           <a:lstStyle/>
           <a:p>
-            <a:fld id="{C823E295-28DF-4E71-9F53-D45207DE2860}" type="datetimeFigureOut">
+            <a:fld id="{18FE2997-B109-4CE4-AFB1-78F134803C95}" type="datetimeFigureOut">
               <a:rPr lang="en-US" smtClean="0"/>
               <a:t>5/20/2026</a:t>
             </a:fld>
@@ -1669,7 +1669,7 @@
           <a:bodyPr/>
           <a:lstStyle/>
           <a:p>
-            <a:fld id="{41970ED4-46CD-4B2B-B2B3-745DA35D2A58}" type="slidenum">
+            <a:fld id="{6B5A31E5-CCDF-45E1-B52C-D30857F2ECD5}" type="slidenum">
               <a:rPr lang="en-US" smtClean="0"/>
               <a:t>‹#›</a:t>
             </a:fld>
@@ -1711,7 +1711,7 @@
     </p:spTree>
     <p:extLst>
       <p:ext uri="{BB962C8B-B14F-4D97-AF65-F5344CB8AC3E}">
-        <p14:creationId xmlns:p14="http://schemas.microsoft.com/office/powerpoint/2010/main" val="2068119275"/>
+        <p14:creationId xmlns:p14="http://schemas.microsoft.com/office/powerpoint/2010/main" val="1531012738"/>
       </p:ext>
     </p:extLst>
   </p:cSld>
@@ -2043,7 +2043,7 @@
           <a:bodyPr/>
           <a:lstStyle/>
           <a:p>
-            <a:fld id="{C823E295-28DF-4E71-9F53-D45207DE2860}" type="datetimeFigureOut">
+            <a:fld id="{18FE2997-B109-4CE4-AFB1-78F134803C95}" type="datetimeFigureOut">
               <a:rPr lang="en-US" smtClean="0"/>
               <a:t>5/20/2026</a:t>
             </a:fld>
@@ -2085,7 +2085,7 @@
           <a:bodyPr/>
           <a:lstStyle/>
           <a:p>
-            <a:fld id="{41970ED4-46CD-4B2B-B2B3-745DA35D2A58}" type="slidenum">
+            <a:fld id="{6B5A31E5-CCDF-45E1-B52C-D30857F2ECD5}" type="slidenum">
               <a:rPr lang="en-US" smtClean="0"/>
               <a:t>‹#›</a:t>
             </a:fld>
@@ -2127,7 +2127,7 @@
     </p:spTree>
     <p:extLst>
       <p:ext uri="{BB962C8B-B14F-4D97-AF65-F5344CB8AC3E}">
-        <p14:creationId xmlns:p14="http://schemas.microsoft.com/office/powerpoint/2010/main" val="2245088258"/>
+        <p14:creationId xmlns:p14="http://schemas.microsoft.com/office/powerpoint/2010/main" val="1394469677"/>
       </p:ext>
     </p:extLst>
   </p:cSld>
@@ -2192,7 +2192,7 @@
           <a:bodyPr/>
           <a:lstStyle/>
           <a:p>
-            <a:fld id="{C823E295-28DF-4E71-9F53-D45207DE2860}" type="datetimeFigureOut">
+            <a:fld id="{18FE2997-B109-4CE4-AFB1-78F134803C95}" type="datetimeFigureOut">
               <a:rPr lang="en-US" smtClean="0"/>
               <a:t>5/20/2026</a:t>
             </a:fld>
@@ -2234,7 +2234,7 @@
           <a:bodyPr/>
           <a:lstStyle/>
           <a:p>
-            <a:fld id="{41970ED4-46CD-4B2B-B2B3-745DA35D2A58}" type="slidenum">
+            <a:fld id="{6B5A31E5-CCDF-45E1-B52C-D30857F2ECD5}" type="slidenum">
               <a:rPr lang="en-US" smtClean="0"/>
               <a:t>‹#›</a:t>
             </a:fld>
@@ -2276,7 +2276,7 @@
     </p:spTree>
     <p:extLst>
       <p:ext uri="{BB962C8B-B14F-4D97-AF65-F5344CB8AC3E}">
-        <p14:creationId xmlns:p14="http://schemas.microsoft.com/office/powerpoint/2010/main" val="1601169459"/>
+        <p14:creationId xmlns:p14="http://schemas.microsoft.com/office/powerpoint/2010/main" val="2938249905"/>
       </p:ext>
     </p:extLst>
   </p:cSld>
@@ -2318,7 +2318,7 @@
           <a:bodyPr/>
           <a:lstStyle/>
           <a:p>
-            <a:fld id="{C823E295-28DF-4E71-9F53-D45207DE2860}" type="datetimeFigureOut">
+            <a:fld id="{18FE2997-B109-4CE4-AFB1-78F134803C95}" type="datetimeFigureOut">
               <a:rPr lang="en-US" smtClean="0"/>
               <a:t>5/20/2026</a:t>
             </a:fld>
@@ -2360,7 +2360,7 @@
           <a:bodyPr/>
           <a:lstStyle/>
           <a:p>
-            <a:fld id="{41970ED4-46CD-4B2B-B2B3-745DA35D2A58}" type="slidenum">
+            <a:fld id="{6B5A31E5-CCDF-45E1-B52C-D30857F2ECD5}" type="slidenum">
               <a:rPr lang="en-US" smtClean="0"/>
               <a:t>‹#›</a:t>
             </a:fld>
@@ -2371,7 +2371,7 @@
     </p:spTree>
     <p:extLst>
       <p:ext uri="{BB962C8B-B14F-4D97-AF65-F5344CB8AC3E}">
-        <p14:creationId xmlns:p14="http://schemas.microsoft.com/office/powerpoint/2010/main" val="1890152302"/>
+        <p14:creationId xmlns:p14="http://schemas.microsoft.com/office/powerpoint/2010/main" val="4021662404"/>
       </p:ext>
     </p:extLst>
   </p:cSld>
@@ -2569,7 +2569,7 @@
           <a:bodyPr/>
           <a:lstStyle/>
           <a:p>
-            <a:fld id="{C823E295-28DF-4E71-9F53-D45207DE2860}" type="datetimeFigureOut">
+            <a:fld id="{18FE2997-B109-4CE4-AFB1-78F134803C95}" type="datetimeFigureOut">
               <a:rPr lang="en-US" smtClean="0"/>
               <a:t>5/20/2026</a:t>
             </a:fld>
@@ -2611,7 +2611,7 @@
           <a:bodyPr/>
           <a:lstStyle/>
           <a:p>
-            <a:fld id="{41970ED4-46CD-4B2B-B2B3-745DA35D2A58}" type="slidenum">
+            <a:fld id="{6B5A31E5-CCDF-45E1-B52C-D30857F2ECD5}" type="slidenum">
               <a:rPr lang="en-US" smtClean="0"/>
               <a:t>‹#›</a:t>
             </a:fld>
@@ -2653,7 +2653,7 @@
     </p:spTree>
     <p:extLst>
       <p:ext uri="{BB962C8B-B14F-4D97-AF65-F5344CB8AC3E}">
-        <p14:creationId xmlns:p14="http://schemas.microsoft.com/office/powerpoint/2010/main" val="3011493387"/>
+        <p14:creationId xmlns:p14="http://schemas.microsoft.com/office/powerpoint/2010/main" val="1006427419"/>
       </p:ext>
     </p:extLst>
   </p:cSld>
@@ -3014,7 +3014,7 @@
             </a:lvl1pPr>
           </a:lstStyle>
           <a:p>
-            <a:fld id="{C823E295-28DF-4E71-9F53-D45207DE2860}" type="datetimeFigureOut">
+            <a:fld id="{18FE2997-B109-4CE4-AFB1-78F134803C95}" type="datetimeFigureOut">
               <a:rPr lang="en-US" smtClean="0"/>
               <a:t>5/20/2026</a:t>
             </a:fld>
@@ -3061,7 +3061,7 @@
           <a:bodyPr/>
           <a:lstStyle/>
           <a:p>
-            <a:fld id="{41970ED4-46CD-4B2B-B2B3-745DA35D2A58}" type="slidenum">
+            <a:fld id="{6B5A31E5-CCDF-45E1-B52C-D30857F2ECD5}" type="slidenum">
               <a:rPr lang="en-US" smtClean="0"/>
               <a:t>‹#›</a:t>
             </a:fld>
@@ -3103,7 +3103,7 @@
     </p:spTree>
     <p:extLst>
       <p:ext uri="{BB962C8B-B14F-4D97-AF65-F5344CB8AC3E}">
-        <p14:creationId xmlns:p14="http://schemas.microsoft.com/office/powerpoint/2010/main" val="3991664244"/>
+        <p14:creationId xmlns:p14="http://schemas.microsoft.com/office/powerpoint/2010/main" val="2638352884"/>
       </p:ext>
     </p:extLst>
   </p:cSld>
@@ -3341,7 +3341,7 @@
             </a:lvl1pPr>
           </a:lstStyle>
           <a:p>
-            <a:fld id="{C823E295-28DF-4E71-9F53-D45207DE2860}" type="datetimeFigureOut">
+            <a:fld id="{18FE2997-B109-4CE4-AFB1-78F134803C95}" type="datetimeFigureOut">
               <a:rPr lang="en-US" smtClean="0"/>
               <a:t>5/20/2026</a:t>
             </a:fld>
@@ -3417,7 +3417,7 @@
             </a:lvl1pPr>
           </a:lstStyle>
           <a:p>
-            <a:fld id="{41970ED4-46CD-4B2B-B2B3-745DA35D2A58}" type="slidenum">
+            <a:fld id="{6B5A31E5-CCDF-45E1-B52C-D30857F2ECD5}" type="slidenum">
               <a:rPr lang="en-US" smtClean="0"/>
               <a:t>‹#›</a:t>
             </a:fld>
@@ -3465,7 +3465,7 @@
     </p:spTree>
     <p:extLst>
       <p:ext uri="{BB962C8B-B14F-4D97-AF65-F5344CB8AC3E}">
-        <p14:creationId xmlns:p14="http://schemas.microsoft.com/office/powerpoint/2010/main" val="3836137012"/>
+        <p14:creationId xmlns:p14="http://schemas.microsoft.com/office/powerpoint/2010/main" val="3380819172"/>
       </p:ext>
     </p:extLst>
   </p:cSld>
@@ -3835,7 +3835,7 @@
           <p:cNvPr id="2" name="Title 1">
             <a:extLst>
               <a:ext uri="{FF2B5EF4-FFF2-40B4-BE49-F238E27FC236}">
-                <a16:creationId xmlns:a16="http://schemas.microsoft.com/office/drawing/2014/main" id="{73280129-A7F3-4127-6A2D-84B3DF842B65}"/>
+                <a16:creationId xmlns:a16="http://schemas.microsoft.com/office/drawing/2014/main" id="{B9017AC9-517C-58C0-438C-E0AD5E0D3994}"/>
               </a:ext>
             </a:extLst>
           </p:cNvPr>
@@ -3865,7 +3865,7 @@
           <p:cNvPr id="3" name="Subtitle 2">
             <a:extLst>
               <a:ext uri="{FF2B5EF4-FFF2-40B4-BE49-F238E27FC236}">
-                <a16:creationId xmlns:a16="http://schemas.microsoft.com/office/drawing/2014/main" id="{B6E4CEC4-8417-3B34-D251-AE71F5713B63}"/>
+                <a16:creationId xmlns:a16="http://schemas.microsoft.com/office/drawing/2014/main" id="{7F6BE1BF-09E0-FDF2-51B0-FF401654FDC3}"/>
               </a:ext>
             </a:extLst>
           </p:cNvPr>
@@ -3901,7 +3901,7 @@
     </p:spTree>
     <p:extLst>
       <p:ext uri="{BB962C8B-B14F-4D97-AF65-F5344CB8AC3E}">
-        <p14:creationId xmlns:p14="http://schemas.microsoft.com/office/powerpoint/2010/main" val="168121721"/>
+        <p14:creationId xmlns:p14="http://schemas.microsoft.com/office/powerpoint/2010/main" val="3251387238"/>
       </p:ext>
     </p:extLst>
   </p:cSld>
@@ -3933,7 +3933,7 @@
           <p:cNvPr id="2" name="Title 1">
             <a:extLst>
               <a:ext uri="{FF2B5EF4-FFF2-40B4-BE49-F238E27FC236}">
-                <a16:creationId xmlns:a16="http://schemas.microsoft.com/office/drawing/2014/main" id="{88AC46CF-605A-5B1E-1405-717D207C4A81}"/>
+                <a16:creationId xmlns:a16="http://schemas.microsoft.com/office/drawing/2014/main" id="{35F5BCF7-009E-390D-BA5F-07C10926F001}"/>
               </a:ext>
             </a:extLst>
           </p:cNvPr>
@@ -3963,7 +3963,7 @@
           <p:cNvPr id="3" name="Text Placeholder 2">
             <a:extLst>
               <a:ext uri="{FF2B5EF4-FFF2-40B4-BE49-F238E27FC236}">
-                <a16:creationId xmlns:a16="http://schemas.microsoft.com/office/drawing/2014/main" id="{F44AF5ED-8046-B8B5-E045-66F151B6D0FF}"/>
+                <a16:creationId xmlns:a16="http://schemas.microsoft.com/office/drawing/2014/main" id="{274F3E30-5402-CB47-9FF4-C5547AE0E042}"/>
               </a:ext>
             </a:extLst>
           </p:cNvPr>
@@ -3977,87 +3977,87 @@
         <p:spPr/>
         <p:txBody>
           <a:bodyPr>
-            <a:normAutofit fontScale="70000" lnSpcReduction="20000"/>
+            <a:normAutofit/>
           </a:bodyPr>
           <a:lstStyle/>
           <a:p>
             <a:r>
-              <a:rPr lang="en-US">
-                <a:latin typeface="Calibri" panose="020F0502020204030204" pitchFamily="34" charset="0"/>
-              </a:rPr>
-              <a:t>Vertex AI Gemini 2.5 - multimodal reasoning for parsing, legal analysis, fraud detection, report synthesis</a:t>
-            </a:r>
-          </a:p>
-          <a:p>
-            <a:r>
-              <a:rPr lang="en-US">
-                <a:latin typeface="Calibri" panose="020F0502020204030204" pitchFamily="34" charset="0"/>
-              </a:rPr>
-              <a:t>Cloud Run - serverless container hosting for FastAPI backend and Next.js frontend; auto-scales per request</a:t>
-            </a:r>
-          </a:p>
-          <a:p>
-            <a:r>
-              <a:rPr lang="en-US">
-                <a:latin typeface="Calibri" panose="020F0502020204030204" pitchFamily="34" charset="0"/>
-              </a:rPr>
-              <a:t>Cloud Storage - signed-URL storage for uploaded land documents</a:t>
-            </a:r>
-          </a:p>
-          <a:p>
-            <a:r>
-              <a:rPr lang="en-US">
-                <a:latin typeface="Calibri" panose="020F0502020204030204" pitchFamily="34" charset="0"/>
-              </a:rPr>
-              <a:t>Firestore - document database for analysis state, bundles, findings, audit trail</a:t>
-            </a:r>
-          </a:p>
-          <a:p>
-            <a:r>
-              <a:rPr lang="en-US">
-                <a:latin typeface="Calibri" panose="020F0502020204030204" pitchFamily="34" charset="0"/>
-              </a:rPr>
-              <a:t>Firebase Authentication - email/password and Google sign-in with secure tokens to the backend</a:t>
-            </a:r>
-          </a:p>
-          <a:p>
-            <a:r>
-              <a:rPr lang="en-US">
-                <a:latin typeface="Calibri" panose="020F0502020204030204" pitchFamily="34" charset="0"/>
-              </a:rPr>
-              <a:t>Cloud Build - GitHub push triggers Docker build, image push, Cloud Run deploy</a:t>
-            </a:r>
-          </a:p>
-          <a:p>
-            <a:r>
-              <a:rPr lang="en-US">
-                <a:latin typeface="Calibri" panose="020F0502020204030204" pitchFamily="34" charset="0"/>
-              </a:rPr>
-              <a:t>Artifact Registry - container image storage for backend and frontend</a:t>
-            </a:r>
-          </a:p>
-          <a:p>
-            <a:r>
-              <a:rPr lang="en-US">
-                <a:latin typeface="Calibri" panose="020F0502020204030204" pitchFamily="34" charset="0"/>
-              </a:rPr>
-              <a:t>Secret Manager - Gemini API keys and Firebase admin credentials at rest</a:t>
-            </a:r>
-          </a:p>
-          <a:p>
-            <a:r>
-              <a:rPr lang="en-US">
-                <a:latin typeface="Calibri" panose="020F0502020204030204" pitchFamily="34" charset="0"/>
-              </a:rPr>
-              <a:t>Cloud Logging &amp; Monitoring - centralised structured logs, latency metrics, error alerting</a:t>
-            </a:r>
-          </a:p>
-          <a:p>
-            <a:r>
-              <a:rPr lang="en-US">
-                <a:latin typeface="Calibri" panose="020F0502020204030204" pitchFamily="34" charset="0"/>
-              </a:rPr>
-              <a:t>IAM - least-privilege service accounts for Cloud Run, Firestore, and GCS</a:t>
+              <a:rPr lang="en-US" sz="1800">
+                <a:latin typeface="Calibri" panose="020F0502020204030204" pitchFamily="34" charset="0"/>
+              </a:rPr>
+              <a:t>Vertex AI Gemini 2.5 - the AI brain that powers every agent</a:t>
+            </a:r>
+          </a:p>
+          <a:p>
+            <a:r>
+              <a:rPr lang="en-US" sz="1800">
+                <a:latin typeface="Calibri" panose="020F0502020204030204" pitchFamily="34" charset="0"/>
+              </a:rPr>
+              <a:t>Cloud Run - serverless hosting for the backend and the frontend</a:t>
+            </a:r>
+          </a:p>
+          <a:p>
+            <a:r>
+              <a:rPr lang="en-US" sz="1800">
+                <a:latin typeface="Calibri" panose="020F0502020204030204" pitchFamily="34" charset="0"/>
+              </a:rPr>
+              <a:t>Cloud Storage - keeps the uploaded land documents</a:t>
+            </a:r>
+          </a:p>
+          <a:p>
+            <a:r>
+              <a:rPr lang="en-US" sz="1800">
+                <a:latin typeface="Calibri" panose="020F0502020204030204" pitchFamily="34" charset="0"/>
+              </a:rPr>
+              <a:t>Firestore - stores analysis results and audit history</a:t>
+            </a:r>
+          </a:p>
+          <a:p>
+            <a:r>
+              <a:rPr lang="en-US" sz="1800">
+                <a:latin typeface="Calibri" panose="020F0502020204030204" pitchFamily="34" charset="0"/>
+              </a:rPr>
+              <a:t>Firebase Authentication - secure login for every user</a:t>
+            </a:r>
+          </a:p>
+          <a:p>
+            <a:r>
+              <a:rPr lang="en-US" sz="1800">
+                <a:latin typeface="Calibri" panose="020F0502020204030204" pitchFamily="34" charset="0"/>
+              </a:rPr>
+              <a:t>Cloud Build - automatic build and deploy on every git push</a:t>
+            </a:r>
+          </a:p>
+          <a:p>
+            <a:r>
+              <a:rPr lang="en-US" sz="1800">
+                <a:latin typeface="Calibri" panose="020F0502020204030204" pitchFamily="34" charset="0"/>
+              </a:rPr>
+              <a:t>Artifact Registry - stores our Docker images</a:t>
+            </a:r>
+          </a:p>
+          <a:p>
+            <a:r>
+              <a:rPr lang="en-US" sz="1800">
+                <a:latin typeface="Calibri" panose="020F0502020204030204" pitchFamily="34" charset="0"/>
+              </a:rPr>
+              <a:t>Secret Manager - keeps API keys and credentials safe</a:t>
+            </a:r>
+          </a:p>
+          <a:p>
+            <a:r>
+              <a:rPr lang="en-US" sz="1800">
+                <a:latin typeface="Calibri" panose="020F0502020204030204" pitchFamily="34" charset="0"/>
+              </a:rPr>
+              <a:t>Cloud Logging and Monitoring - shows how the app is performing</a:t>
+            </a:r>
+          </a:p>
+          <a:p>
+            <a:r>
+              <a:rPr lang="en-US" sz="1800">
+                <a:latin typeface="Calibri" panose="020F0502020204030204" pitchFamily="34" charset="0"/>
+              </a:rPr>
+              <a:t>IAM - controls what each service is allowed to do</a:t>
             </a:r>
           </a:p>
         </p:txBody>
@@ -4065,7 +4065,7 @@
     </p:spTree>
     <p:extLst>
       <p:ext uri="{BB962C8B-B14F-4D97-AF65-F5344CB8AC3E}">
-        <p14:creationId xmlns:p14="http://schemas.microsoft.com/office/powerpoint/2010/main" val="2056414596"/>
+        <p14:creationId xmlns:p14="http://schemas.microsoft.com/office/powerpoint/2010/main" val="1205382556"/>
       </p:ext>
     </p:extLst>
   </p:cSld>
@@ -4097,7 +4097,7 @@
           <p:cNvPr id="2" name="Title 1">
             <a:extLst>
               <a:ext uri="{FF2B5EF4-FFF2-40B4-BE49-F238E27FC236}">
-                <a16:creationId xmlns:a16="http://schemas.microsoft.com/office/drawing/2014/main" id="{26B9160E-548B-9B03-C0F2-ED881EF1079C}"/>
+                <a16:creationId xmlns:a16="http://schemas.microsoft.com/office/drawing/2014/main" id="{39B8B67F-FBD3-4184-B8DE-06C843E82180}"/>
               </a:ext>
             </a:extLst>
           </p:cNvPr>
@@ -4127,7 +4127,7 @@
           <p:cNvPr id="3" name="Text Placeholder 2">
             <a:extLst>
               <a:ext uri="{FF2B5EF4-FFF2-40B4-BE49-F238E27FC236}">
-                <a16:creationId xmlns:a16="http://schemas.microsoft.com/office/drawing/2014/main" id="{DB220687-932F-1C37-E6FF-90927195D4C1}"/>
+                <a16:creationId xmlns:a16="http://schemas.microsoft.com/office/drawing/2014/main" id="{79F156E7-94BC-66B0-167B-2ED973D1A670}"/>
               </a:ext>
             </a:extLst>
           </p:cNvPr>
@@ -4149,7 +4149,7 @@
               <a:rPr lang="en-US" sz="1800">
                 <a:latin typeface="Calibri" panose="020F0502020204030204" pitchFamily="34" charset="0"/>
               </a:rPr>
-              <a:t>Problem observed: Indian land transactions involve 8-10 documents per deal; buyers cannot verify them alone</a:t>
+              <a:t>Land deals in India use 8 to 10 documents - most buyers cannot verify them on their own</a:t>
             </a:r>
           </a:p>
           <a:p>
@@ -4157,7 +4157,7 @@
               <a:rPr lang="en-US" sz="1800">
                 <a:latin typeface="Calibri" panose="020F0502020204030204" pitchFamily="34" charset="0"/>
               </a:rPr>
-              <a:t>Lawyers are expensive and slow; fraud patterns (Roshni Act, tribal land, benami) are hard to spot manually</a:t>
+              <a:t>Lawyers help, but are slow and expensive - and fraud patterns are hard to spot manually</a:t>
             </a:r>
           </a:p>
           <a:p>
@@ -4165,7 +4165,7 @@
               <a:rPr lang="en-US" sz="1800">
                 <a:latin typeface="Calibri" panose="020F0502020204030204" pitchFamily="34" charset="0"/>
               </a:rPr>
-              <a:t>Why an AI agent: Gemini 2.5 reads multi-page PDFs natively and extracts structured fields with high accuracy</a:t>
+              <a:t>Gemini can read multi-page PDFs directly, which removes the need for any separate OCR step</a:t>
             </a:r>
           </a:p>
           <a:p>
@@ -4173,7 +4173,7 @@
               <a:rPr lang="en-US" sz="1800">
                 <a:latin typeface="Calibri" panose="020F0502020204030204" pitchFamily="34" charset="0"/>
               </a:rPr>
-              <a:t>A multi-agent layout runs parser, legal, fraud, and report agents in parallel with focused prompts</a:t>
+              <a:t>Splitting the job across small focused agents gave us better accuracy than one giant prompt</a:t>
             </a:r>
           </a:p>
           <a:p>
@@ -4181,7 +4181,7 @@
               <a:rPr lang="en-US" sz="1800">
                 <a:latin typeface="Calibri" panose="020F0502020204030204" pitchFamily="34" charset="0"/>
               </a:rPr>
-              <a:t>Findings are consolidated and graded, so the user gets a lawyer-style summary, not raw text</a:t>
+              <a:t>Running the agents in parallel keeps the user experience fast</a:t>
             </a:r>
           </a:p>
           <a:p>
@@ -4189,7 +4189,7 @@
               <a:rPr lang="en-US" sz="1800">
                 <a:latin typeface="Calibri" panose="020F0502020204030204" pitchFamily="34" charset="0"/>
               </a:rPr>
-              <a:t>Why Google Cloud: Vertex AI Gemini gives best-in-class multimodal reasoning without managing models ourselves</a:t>
+              <a:t>Google Cloud gives us everything in one place - AI, hosting, storage, login and security</a:t>
             </a:r>
           </a:p>
           <a:p>
@@ -4197,15 +4197,7 @@
               <a:rPr lang="en-US" sz="1800">
                 <a:latin typeface="Calibri" panose="020F0502020204030204" pitchFamily="34" charset="0"/>
               </a:rPr>
-              <a:t>Cloud Run + Firestore scales from one document to thousands without infra work</a:t>
-            </a:r>
-          </a:p>
-          <a:p>
-            <a:r>
-              <a:rPr lang="en-US" sz="1800">
-                <a:latin typeface="Calibri" panose="020F0502020204030204" pitchFamily="34" charset="0"/>
-              </a:rPr>
-              <a:t>Firebase Auth + IAM gives a clean security boundary for sensitive land data</a:t>
+              <a:t>End result: a non-expert buyer gets a clear answer in under a minute, not weeks</a:t>
             </a:r>
           </a:p>
         </p:txBody>
@@ -4213,7 +4205,7 @@
     </p:spTree>
     <p:extLst>
       <p:ext uri="{BB962C8B-B14F-4D97-AF65-F5344CB8AC3E}">
-        <p14:creationId xmlns:p14="http://schemas.microsoft.com/office/powerpoint/2010/main" val="2951519474"/>
+        <p14:creationId xmlns:p14="http://schemas.microsoft.com/office/powerpoint/2010/main" val="2211322784"/>
       </p:ext>
     </p:extLst>
   </p:cSld>
@@ -4245,7 +4237,7 @@
           <p:cNvPr id="2" name="Title 1">
             <a:extLst>
               <a:ext uri="{FF2B5EF4-FFF2-40B4-BE49-F238E27FC236}">
-                <a16:creationId xmlns:a16="http://schemas.microsoft.com/office/drawing/2014/main" id="{A6620D0E-ED1D-DA09-5128-9FE6564C8F19}"/>
+                <a16:creationId xmlns:a16="http://schemas.microsoft.com/office/drawing/2014/main" id="{5F7C0590-F077-414D-7AD5-464644BED50D}"/>
               </a:ext>
             </a:extLst>
           </p:cNvPr>
@@ -4275,7 +4267,7 @@
           <p:cNvPr id="3" name="Subtitle 2">
             <a:extLst>
               <a:ext uri="{FF2B5EF4-FFF2-40B4-BE49-F238E27FC236}">
-                <a16:creationId xmlns:a16="http://schemas.microsoft.com/office/drawing/2014/main" id="{BF06D22F-AB46-628C-4B6F-F4A8A601643C}"/>
+                <a16:creationId xmlns:a16="http://schemas.microsoft.com/office/drawing/2014/main" id="{24D08EFD-4430-5B7C-360F-7B5B061A6DE7}"/>
               </a:ext>
             </a:extLst>
           </p:cNvPr>
@@ -4303,7 +4295,7 @@
     </p:spTree>
     <p:extLst>
       <p:ext uri="{BB962C8B-B14F-4D97-AF65-F5344CB8AC3E}">
-        <p14:creationId xmlns:p14="http://schemas.microsoft.com/office/powerpoint/2010/main" val="800917708"/>
+        <p14:creationId xmlns:p14="http://schemas.microsoft.com/office/powerpoint/2010/main" val="4090857286"/>
       </p:ext>
     </p:extLst>
   </p:cSld>
@@ -4335,7 +4327,7 @@
           <p:cNvPr id="2" name="Title 1">
             <a:extLst>
               <a:ext uri="{FF2B5EF4-FFF2-40B4-BE49-F238E27FC236}">
-                <a16:creationId xmlns:a16="http://schemas.microsoft.com/office/drawing/2014/main" id="{FD9167F9-C11D-515A-460E-8F2147221331}"/>
+                <a16:creationId xmlns:a16="http://schemas.microsoft.com/office/drawing/2014/main" id="{579F97A2-78F7-1512-CD72-25F23D72C39B}"/>
               </a:ext>
             </a:extLst>
           </p:cNvPr>
@@ -4365,7 +4357,7 @@
           <p:cNvPr id="3" name="Text Placeholder 2">
             <a:extLst>
               <a:ext uri="{FF2B5EF4-FFF2-40B4-BE49-F238E27FC236}">
-                <a16:creationId xmlns:a16="http://schemas.microsoft.com/office/drawing/2014/main" id="{DE7B7420-A57B-1A32-29CD-A44CA36B3D66}"/>
+                <a16:creationId xmlns:a16="http://schemas.microsoft.com/office/drawing/2014/main" id="{9E460256-12E8-A170-6640-20E504B83EE1}"/>
               </a:ext>
             </a:extLst>
           </p:cNvPr>
@@ -4379,7 +4371,7 @@
         <p:spPr/>
         <p:txBody>
           <a:bodyPr>
-            <a:normAutofit lnSpcReduction="10000"/>
+            <a:normAutofit/>
           </a:bodyPr>
           <a:lstStyle/>
           <a:p>
@@ -4387,7 +4379,7 @@
               <a:rPr lang="en-US" sz="1800">
                 <a:latin typeface="Calibri" panose="020F0502020204030204" pitchFamily="34" charset="0"/>
               </a:rPr>
-              <a:t>Team: Landshield - Member: Abhishek Partap S - DU: AI Altitude</a:t>
+              <a:t>Team Landshield - Abhishek Partap S - DU: AI Altitude</a:t>
             </a:r>
           </a:p>
           <a:p>
@@ -4395,7 +4387,7 @@
               <a:rPr lang="en-US" sz="1800">
                 <a:latin typeface="Calibri" panose="020F0502020204030204" pitchFamily="34" charset="0"/>
               </a:rPr>
-              <a:t>Use case: AI-powered land document verification for Indian buyers</a:t>
+              <a:t>Domain: Real Estate and Legal Tech - verifying land documents for Indian buyers</a:t>
             </a:r>
           </a:p>
           <a:p>
@@ -4403,7 +4395,7 @@
               <a:rPr lang="en-US" sz="1800">
                 <a:latin typeface="Calibri" panose="020F0502020204030204" pitchFamily="34" charset="0"/>
               </a:rPr>
-              <a:t>Domain: Real Estate / Legal Tech - Sub-domain: Document verification, fraud detection, due-diligence assistance</a:t>
+              <a:t>Problem: buying land in India needs 8 to 10 documents - one wrong paper and the buyer loses everything</a:t>
             </a:r>
           </a:p>
           <a:p>
@@ -4411,7 +4403,7 @@
               <a:rPr lang="en-US" sz="1800">
                 <a:latin typeface="Calibri" panose="020F0502020204030204" pitchFamily="34" charset="0"/>
               </a:rPr>
-              <a:t>What it does: Ingests a bundle of land documents (sale deed, EC, mutation, tax receipt, building plan), extracts structured data, validates against Indian land law (TPA, Roshni Act, tribal-land rules, RERA), flags fraud indicators, and produces a lawyer-style report graded by severity</a:t>
+              <a:t>Solution: an AI assistant that reads the full bundle - sale deed, EC, mutation, tax receipt, building plan</a:t>
             </a:r>
           </a:p>
           <a:p>
@@ -4419,7 +4411,15 @@
               <a:rPr lang="en-US" sz="1800">
                 <a:latin typeface="Calibri" panose="020F0502020204030204" pitchFamily="34" charset="0"/>
               </a:rPr>
-              <a:t>Outcome: Buyer gets a clear go / clarify / stop verdict in seconds instead of weeks of manual due diligence</a:t>
+              <a:t>It checks the documents against Indian land law and flags fraud signs in plain language</a:t>
+            </a:r>
+          </a:p>
+          <a:p>
+            <a:r>
+              <a:rPr lang="en-US" sz="1800">
+                <a:latin typeface="Calibri" panose="020F0502020204030204" pitchFamily="34" charset="0"/>
+              </a:rPr>
+              <a:t>Outcome: the buyer gets a clear Go, Clarify or Stop answer in under a minute, not weeks</a:t>
             </a:r>
           </a:p>
         </p:txBody>
@@ -4427,7 +4427,7 @@
     </p:spTree>
     <p:extLst>
       <p:ext uri="{BB962C8B-B14F-4D97-AF65-F5344CB8AC3E}">
-        <p14:creationId xmlns:p14="http://schemas.microsoft.com/office/powerpoint/2010/main" val="3802166759"/>
+        <p14:creationId xmlns:p14="http://schemas.microsoft.com/office/powerpoint/2010/main" val="1917626762"/>
       </p:ext>
     </p:extLst>
   </p:cSld>
@@ -4459,7 +4459,7 @@
           <p:cNvPr id="2" name="Title 1">
             <a:extLst>
               <a:ext uri="{FF2B5EF4-FFF2-40B4-BE49-F238E27FC236}">
-                <a16:creationId xmlns:a16="http://schemas.microsoft.com/office/drawing/2014/main" id="{22EA5A2B-DF2E-A2D5-74CB-D7A399C062B1}"/>
+                <a16:creationId xmlns:a16="http://schemas.microsoft.com/office/drawing/2014/main" id="{167E825B-F72E-3005-A28C-2E59E740BCAE}"/>
               </a:ext>
             </a:extLst>
           </p:cNvPr>
@@ -4489,7 +4489,7 @@
           <p:cNvPr id="3" name="Text Placeholder 2">
             <a:extLst>
               <a:ext uri="{FF2B5EF4-FFF2-40B4-BE49-F238E27FC236}">
-                <a16:creationId xmlns:a16="http://schemas.microsoft.com/office/drawing/2014/main" id="{D4E79055-AB7E-B5F9-5708-5318A398C894}"/>
+                <a16:creationId xmlns:a16="http://schemas.microsoft.com/office/drawing/2014/main" id="{5C99AF65-3BF3-8B7E-39D8-8BEA070BDA87}"/>
               </a:ext>
             </a:extLst>
           </p:cNvPr>
@@ -4503,7 +4503,7 @@
         <p:spPr/>
         <p:txBody>
           <a:bodyPr>
-            <a:normAutofit fontScale="70000" lnSpcReduction="20000"/>
+            <a:normAutofit fontScale="85000" lnSpcReduction="10000"/>
           </a:bodyPr>
           <a:lstStyle/>
           <a:p>
@@ -4511,7 +4511,7 @@
               <a:rPr lang="en-US">
                 <a:latin typeface="Calibri" panose="020F0502020204030204" pitchFamily="34" charset="0"/>
               </a:rPr>
-              <a:t>Orchestrator (FastAPI on Cloud Run): receives the bundle, fans out parallel agent calls, streams progress via SSE, persists to Firestore</a:t>
+              <a:t>Orchestrator: a backend that takes the documents and runs the four AI agents in order</a:t>
             </a:r>
           </a:p>
           <a:p>
@@ -4519,7 +4519,7 @@
               <a:rPr lang="en-US">
                 <a:latin typeface="Calibri" panose="020F0502020204030204" pitchFamily="34" charset="0"/>
               </a:rPr>
-              <a:t>Parser Agent (Gemini): reads PDFs natively, extracts parties, area, stamp duty, registration details, chain of title, dates</a:t>
+              <a:t>Parser Agent: reads each PDF and pulls out names, area, dates, stamp duty and registration details</a:t>
             </a:r>
           </a:p>
           <a:p>
@@ -4527,7 +4527,7 @@
               <a:rPr lang="en-US">
                 <a:latin typeface="Calibri" panose="020F0502020204030204" pitchFamily="34" charset="0"/>
               </a:rPr>
-              <a:t>Legal Rules Agent (Gemini): maps extracted data against Indian land law - registration, stamp duty, state restrictions, RERA</a:t>
+              <a:t>Legal Agent: checks if the documents follow Indian land law and flags any non-compliance</a:t>
             </a:r>
           </a:p>
           <a:p>
@@ -4535,7 +4535,7 @@
               <a:rPr lang="en-US">
                 <a:latin typeface="Calibri" panose="020F0502020204030204" pitchFamily="34" charset="0"/>
               </a:rPr>
-              <a:t>Fraud Detection Agent (Gemini): flags name mismatches, chain-of-title gaps, undervaluation, fake registration patterns</a:t>
+              <a:t>Fraud Agent: looks for red flags like name mismatches, broken ownership chains and undervaluation</a:t>
             </a:r>
           </a:p>
           <a:p>
@@ -4543,7 +4543,7 @@
               <a:rPr lang="en-US">
                 <a:latin typeface="Calibri" panose="020F0502020204030204" pitchFamily="34" charset="0"/>
               </a:rPr>
-              <a:t>Report Agent (Gemini): consolidates findings into a lawyer-style summary with severity grading and recommendations</a:t>
+              <a:t>Report Agent: combines all findings into a short summary with a severity grade and next steps</a:t>
             </a:r>
           </a:p>
           <a:p>
@@ -4551,7 +4551,7 @@
               <a:rPr lang="en-US">
                 <a:latin typeface="Calibri" panose="020F0502020204030204" pitchFamily="34" charset="0"/>
               </a:rPr>
-              <a:t>Storage: GCS for source PDFs (signed URLs), Firestore for analysis state and audit log</a:t>
+              <a:t>Frontend: a simple web app that shows live progress and the final report, secured by Firebase login</a:t>
             </a:r>
           </a:p>
           <a:p>
@@ -4559,7 +4559,7 @@
               <a:rPr lang="en-US">
                 <a:latin typeface="Calibri" panose="020F0502020204030204" pitchFamily="34" charset="0"/>
               </a:rPr>
-              <a:t>Frontend (Next.js on Cloud Run): dashboard, upload, real-time progress, report viewer - Firebase Auth gates access</a:t>
+              <a:t>Storage: documents in Cloud Storage, results and audit trail in Firestore</a:t>
             </a:r>
           </a:p>
           <a:p>
@@ -4567,7 +4567,7 @@
               <a:rPr lang="en-US">
                 <a:latin typeface="Calibri" panose="020F0502020204030204" pitchFamily="34" charset="0"/>
               </a:rPr>
-              <a:t>Observability: Cloud Logging + Monitoring - structured logs, agent latency, model cost, alerts</a:t>
+              <a:t>Everything is monitored: logs, latency and errors are tracked in Google Cloud Monitoring</a:t>
             </a:r>
           </a:p>
         </p:txBody>
@@ -4575,7 +4575,7 @@
     </p:spTree>
     <p:extLst>
       <p:ext uri="{BB962C8B-B14F-4D97-AF65-F5344CB8AC3E}">
-        <p14:creationId xmlns:p14="http://schemas.microsoft.com/office/powerpoint/2010/main" val="1730191215"/>
+        <p14:creationId xmlns:p14="http://schemas.microsoft.com/office/powerpoint/2010/main" val="112257012"/>
       </p:ext>
     </p:extLst>
   </p:cSld>
@@ -4607,7 +4607,7 @@
           <p:cNvPr id="2" name="Title 1">
             <a:extLst>
               <a:ext uri="{FF2B5EF4-FFF2-40B4-BE49-F238E27FC236}">
-                <a16:creationId xmlns:a16="http://schemas.microsoft.com/office/drawing/2014/main" id="{5212977E-9183-30CE-987A-4555196586F7}"/>
+                <a16:creationId xmlns:a16="http://schemas.microsoft.com/office/drawing/2014/main" id="{A12ACFB7-70DA-1DCD-360C-5CBCF48C2498}"/>
               </a:ext>
             </a:extLst>
           </p:cNvPr>
@@ -4637,7 +4637,7 @@
           <p:cNvPr id="3" name="Rectangle: Rounded Corners 2">
             <a:extLst>
               <a:ext uri="{FF2B5EF4-FFF2-40B4-BE49-F238E27FC236}">
-                <a16:creationId xmlns:a16="http://schemas.microsoft.com/office/drawing/2014/main" id="{C0B1B94F-7591-FB51-EAEB-121FA56712FF}"/>
+                <a16:creationId xmlns:a16="http://schemas.microsoft.com/office/drawing/2014/main" id="{E6CD40AB-5B64-0C44-75B4-E17F164FE59B}"/>
               </a:ext>
             </a:extLst>
           </p:cNvPr>
@@ -4699,7 +4699,7 @@
                 </a:solidFill>
                 <a:latin typeface="Calibri" panose="020F0502020204030204" pitchFamily="34" charset="0"/>
               </a:rPr>
-              <a:t>Next.js frontend on Cloud Run - Firebase Auth - dashboard - upload - real-time progress - report viewer</a:t>
+              <a:t>Next.js web app on Cloud Run - login, upload, live progress, final report</a:t>
             </a:r>
           </a:p>
         </p:txBody>
@@ -4709,7 +4709,7 @@
           <p:cNvPr id="4" name="Rectangle: Rounded Corners 3">
             <a:extLst>
               <a:ext uri="{FF2B5EF4-FFF2-40B4-BE49-F238E27FC236}">
-                <a16:creationId xmlns:a16="http://schemas.microsoft.com/office/drawing/2014/main" id="{5191654B-A031-CF93-A274-42970767BACB}"/>
+                <a16:creationId xmlns:a16="http://schemas.microsoft.com/office/drawing/2014/main" id="{2A0C2F08-399A-39AA-D5B0-911C70858CAF}"/>
               </a:ext>
             </a:extLst>
           </p:cNvPr>
@@ -4771,7 +4771,7 @@
                 </a:solidFill>
                 <a:latin typeface="Calibri" panose="020F0502020204030204" pitchFamily="34" charset="0"/>
               </a:rPr>
-              <a:t>FastAPI orchestrator on Cloud Run - SSE streaming - fans out parallel agent calls - persists state to Firestore</a:t>
+              <a:t>FastAPI backend on Cloud Run - runs the agents, streams progress, saves results</a:t>
             </a:r>
           </a:p>
         </p:txBody>
@@ -4781,7 +4781,7 @@
           <p:cNvPr id="5" name="Rectangle: Rounded Corners 4">
             <a:extLst>
               <a:ext uri="{FF2B5EF4-FFF2-40B4-BE49-F238E27FC236}">
-                <a16:creationId xmlns:a16="http://schemas.microsoft.com/office/drawing/2014/main" id="{9BA010C3-84CE-59EA-A908-C26A8F0FC4C5}"/>
+                <a16:creationId xmlns:a16="http://schemas.microsoft.com/office/drawing/2014/main" id="{C10A160D-A6FA-D493-4CF6-AB6FEE4A975F}"/>
               </a:ext>
             </a:extLst>
           </p:cNvPr>
@@ -4842,7 +4842,7 @@
           <p:cNvPr id="6" name="Rectangle: Rounded Corners 5">
             <a:extLst>
               <a:ext uri="{FF2B5EF4-FFF2-40B4-BE49-F238E27FC236}">
-                <a16:creationId xmlns:a16="http://schemas.microsoft.com/office/drawing/2014/main" id="{44FFE5E5-A2C4-197F-5E4B-BDA1D1A2E5C8}"/>
+                <a16:creationId xmlns:a16="http://schemas.microsoft.com/office/drawing/2014/main" id="{F37E7E6D-0178-600E-8921-E109CE594CDF}"/>
               </a:ext>
             </a:extLst>
           </p:cNvPr>
@@ -4916,7 +4916,7 @@
           <p:cNvPr id="7" name="Rectangle: Rounded Corners 6">
             <a:extLst>
               <a:ext uri="{FF2B5EF4-FFF2-40B4-BE49-F238E27FC236}">
-                <a16:creationId xmlns:a16="http://schemas.microsoft.com/office/drawing/2014/main" id="{EF76CF58-B15F-B8BF-8DDC-C4EC812862E4}"/>
+                <a16:creationId xmlns:a16="http://schemas.microsoft.com/office/drawing/2014/main" id="{91FAB30E-D6A5-50D1-3402-EABD47436EF2}"/>
               </a:ext>
             </a:extLst>
           </p:cNvPr>
@@ -4990,7 +4990,7 @@
           <p:cNvPr id="8" name="Rectangle: Rounded Corners 7">
             <a:extLst>
               <a:ext uri="{FF2B5EF4-FFF2-40B4-BE49-F238E27FC236}">
-                <a16:creationId xmlns:a16="http://schemas.microsoft.com/office/drawing/2014/main" id="{0331C2DA-28C1-882B-7BE1-6BD6E6E657FB}"/>
+                <a16:creationId xmlns:a16="http://schemas.microsoft.com/office/drawing/2014/main" id="{A659EFAF-C565-C93E-AA21-CE7B224C303E}"/>
               </a:ext>
             </a:extLst>
           </p:cNvPr>
@@ -5064,7 +5064,7 @@
           <p:cNvPr id="9" name="Rectangle: Rounded Corners 8">
             <a:extLst>
               <a:ext uri="{FF2B5EF4-FFF2-40B4-BE49-F238E27FC236}">
-                <a16:creationId xmlns:a16="http://schemas.microsoft.com/office/drawing/2014/main" id="{9DC632A2-D704-0F4A-1C30-46F0EE4A01E3}"/>
+                <a16:creationId xmlns:a16="http://schemas.microsoft.com/office/drawing/2014/main" id="{0E06A8F4-A78B-3F5C-7964-17A9152A47A0}"/>
               </a:ext>
             </a:extLst>
           </p:cNvPr>
@@ -5138,7 +5138,7 @@
           <p:cNvPr id="10" name="Rectangle: Rounded Corners 9">
             <a:extLst>
               <a:ext uri="{FF2B5EF4-FFF2-40B4-BE49-F238E27FC236}">
-                <a16:creationId xmlns:a16="http://schemas.microsoft.com/office/drawing/2014/main" id="{08D1A91E-AC68-81DE-366F-3DDD81DB5F20}"/>
+                <a16:creationId xmlns:a16="http://schemas.microsoft.com/office/drawing/2014/main" id="{63FE0091-EBAC-6A46-F1E6-FC85D2D91068}"/>
               </a:ext>
             </a:extLst>
           </p:cNvPr>
@@ -5200,7 +5200,7 @@
                 </a:solidFill>
                 <a:latin typeface="Calibri" panose="020F0502020204030204" pitchFamily="34" charset="0"/>
               </a:rPr>
-              <a:t>GCS (PDFs, signed URLs) - Firestore (findings, audit log)</a:t>
+              <a:t>Cloud Storage for PDFs - Firestore for results and audit log</a:t>
             </a:r>
           </a:p>
         </p:txBody>
@@ -5210,7 +5210,7 @@
           <p:cNvPr id="11" name="Rectangle: Rounded Corners 10">
             <a:extLst>
               <a:ext uri="{FF2B5EF4-FFF2-40B4-BE49-F238E27FC236}">
-                <a16:creationId xmlns:a16="http://schemas.microsoft.com/office/drawing/2014/main" id="{71B587ED-6818-D6C6-01A5-AA85C2229F76}"/>
+                <a16:creationId xmlns:a16="http://schemas.microsoft.com/office/drawing/2014/main" id="{1BAA3400-EDBD-28F8-4BD8-9DCDEB51DBBA}"/>
               </a:ext>
             </a:extLst>
           </p:cNvPr>
@@ -5261,7 +5261,7 @@
                 </a:solidFill>
                 <a:latin typeface="Calibri" panose="020F0502020204030204" pitchFamily="34" charset="0"/>
               </a:rPr>
-              <a:t>CROSS-CUTTING</a:t>
+              <a:t>SECURITY and OPERATIONS</a:t>
             </a:r>
           </a:p>
           <a:p>
@@ -5272,7 +5272,7 @@
                 </a:solidFill>
                 <a:latin typeface="Calibri" panose="020F0502020204030204" pitchFamily="34" charset="0"/>
               </a:rPr>
-              <a:t>Cloud Logging - Monitoring - IAM - Secret Manager - Artifact Registry</a:t>
+              <a:t>Logging, Monitoring, IAM, Secret Manager, Artifact Registry</a:t>
             </a:r>
           </a:p>
         </p:txBody>
@@ -5280,7 +5280,7 @@
     </p:spTree>
     <p:extLst>
       <p:ext uri="{BB962C8B-B14F-4D97-AF65-F5344CB8AC3E}">
-        <p14:creationId xmlns:p14="http://schemas.microsoft.com/office/powerpoint/2010/main" val="3385334765"/>
+        <p14:creationId xmlns:p14="http://schemas.microsoft.com/office/powerpoint/2010/main" val="3265047314"/>
       </p:ext>
     </p:extLst>
   </p:cSld>
@@ -5312,7 +5312,7 @@
           <p:cNvPr id="2" name="Title 1">
             <a:extLst>
               <a:ext uri="{FF2B5EF4-FFF2-40B4-BE49-F238E27FC236}">
-                <a16:creationId xmlns:a16="http://schemas.microsoft.com/office/drawing/2014/main" id="{C46EF0DB-4810-CC5D-F50D-2D205C7210A2}"/>
+                <a16:creationId xmlns:a16="http://schemas.microsoft.com/office/drawing/2014/main" id="{5658168E-9A6F-2B24-6A17-F8647DD69BF1}"/>
               </a:ext>
             </a:extLst>
           </p:cNvPr>
@@ -5342,7 +5342,7 @@
           <p:cNvPr id="3" name="Text Placeholder 2">
             <a:extLst>
               <a:ext uri="{FF2B5EF4-FFF2-40B4-BE49-F238E27FC236}">
-                <a16:creationId xmlns:a16="http://schemas.microsoft.com/office/drawing/2014/main" id="{F6E5D678-AAF4-B438-2301-939B4765BDC8}"/>
+                <a16:creationId xmlns:a16="http://schemas.microsoft.com/office/drawing/2014/main" id="{C63184A2-96B5-5AAE-BB02-B83B4842C71A}"/>
               </a:ext>
             </a:extLst>
           </p:cNvPr>
@@ -5356,79 +5356,71 @@
         <p:spPr/>
         <p:txBody>
           <a:bodyPr>
-            <a:normAutofit fontScale="85000" lnSpcReduction="20000"/>
+            <a:normAutofit lnSpcReduction="10000"/>
           </a:bodyPr>
           <a:lstStyle/>
           <a:p>
             <a:r>
-              <a:rPr lang="en-US">
-                <a:latin typeface="Calibri" panose="020F0502020204030204" pitchFamily="34" charset="0"/>
-              </a:rPr>
-              <a:t>User uploads a bundle of land documents and selects state + land type</a:t>
-            </a:r>
-          </a:p>
-          <a:p>
-            <a:r>
-              <a:rPr lang="en-US">
-                <a:latin typeface="Calibri" panose="020F0502020204030204" pitchFamily="34" charset="0"/>
-              </a:rPr>
-              <a:t>Frontend pushes files to backend; backend stores them in GCS and creates a Firestore record</a:t>
-            </a:r>
-          </a:p>
-          <a:p>
-            <a:r>
-              <a:rPr lang="en-US">
-                <a:latin typeface="Calibri" panose="020F0502020204030204" pitchFamily="34" charset="0"/>
-              </a:rPr>
-              <a:t>Orchestrator triggers Parser Agent; Gemini reads each PDF and extracts structured fields</a:t>
-            </a:r>
-          </a:p>
-          <a:p>
-            <a:r>
-              <a:rPr lang="en-US">
-                <a:latin typeface="Calibri" panose="020F0502020204030204" pitchFamily="34" charset="0"/>
-              </a:rPr>
-              <a:t>Legal Rules Agent and Fraud Detection Agent run in parallel on the extracted data</a:t>
-            </a:r>
-          </a:p>
-          <a:p>
-            <a:r>
-              <a:rPr lang="en-US">
-                <a:latin typeface="Calibri" panose="020F0502020204030204" pitchFamily="34" charset="0"/>
-              </a:rPr>
-              <a:t>Findings are normalised, deduplicated, consolidated, and graded by severity</a:t>
-            </a:r>
-          </a:p>
-          <a:p>
-            <a:r>
-              <a:rPr lang="en-US">
-                <a:latin typeface="Calibri" panose="020F0502020204030204" pitchFamily="34" charset="0"/>
-              </a:rPr>
-              <a:t>Report Agent generates a lawyer-style summary with severity counts and recommended actions</a:t>
-            </a:r>
-          </a:p>
-          <a:p>
-            <a:r>
-              <a:rPr lang="en-US">
-                <a:latin typeface="Calibri" panose="020F0502020204030204" pitchFamily="34" charset="0"/>
-              </a:rPr>
-              <a:t>Backend persists the report to Firestore and streams progress to the frontend via SSE</a:t>
-            </a:r>
-          </a:p>
-          <a:p>
-            <a:r>
-              <a:rPr lang="en-US">
-                <a:latin typeface="Calibri" panose="020F0502020204030204" pitchFamily="34" charset="0"/>
-              </a:rPr>
-              <a:t>User views the report: property facts, findings, checklist, parties, document inventory</a:t>
-            </a:r>
-          </a:p>
-          <a:p>
-            <a:r>
-              <a:rPr lang="en-US">
-                <a:latin typeface="Calibri" panose="020F0502020204030204" pitchFamily="34" charset="0"/>
-              </a:rPr>
-              <a:t>Cloud Logging and Monitoring capture latency, errors, and cost throughout</a:t>
+              <a:rPr lang="en-US" sz="1800">
+                <a:latin typeface="Calibri" panose="020F0502020204030204" pitchFamily="34" charset="0"/>
+              </a:rPr>
+              <a:t>User logs in, picks the state and land type, and uploads the document bundle</a:t>
+            </a:r>
+          </a:p>
+          <a:p>
+            <a:r>
+              <a:rPr lang="en-US" sz="1800">
+                <a:latin typeface="Calibri" panose="020F0502020204030204" pitchFamily="34" charset="0"/>
+              </a:rPr>
+              <a:t>Files are saved to Cloud Storage and a new analysis record is created in Firestore</a:t>
+            </a:r>
+          </a:p>
+          <a:p>
+            <a:r>
+              <a:rPr lang="en-US" sz="1800">
+                <a:latin typeface="Calibri" panose="020F0502020204030204" pitchFamily="34" charset="0"/>
+              </a:rPr>
+              <a:t>Parser Agent reads each PDF and extracts the key facts</a:t>
+            </a:r>
+          </a:p>
+          <a:p>
+            <a:r>
+              <a:rPr lang="en-US" sz="1800">
+                <a:latin typeface="Calibri" panose="020F0502020204030204" pitchFamily="34" charset="0"/>
+              </a:rPr>
+              <a:t>Legal Agent and Fraud Agent run at the same time on those facts</a:t>
+            </a:r>
+          </a:p>
+          <a:p>
+            <a:r>
+              <a:rPr lang="en-US" sz="1800">
+                <a:latin typeface="Calibri" panose="020F0502020204030204" pitchFamily="34" charset="0"/>
+              </a:rPr>
+              <a:t>Findings are deduplicated and graded as Low, Medium, High or Critical</a:t>
+            </a:r>
+          </a:p>
+          <a:p>
+            <a:r>
+              <a:rPr lang="en-US" sz="1800">
+                <a:latin typeface="Calibri" panose="020F0502020204030204" pitchFamily="34" charset="0"/>
+              </a:rPr>
+              <a:t>Report Agent writes a short summary with clear next steps</a:t>
+            </a:r>
+          </a:p>
+          <a:p>
+            <a:r>
+              <a:rPr lang="en-US" sz="1800">
+                <a:latin typeface="Calibri" panose="020F0502020204030204" pitchFamily="34" charset="0"/>
+              </a:rPr>
+              <a:t>Backend streams progress live; frontend shows the final report</a:t>
+            </a:r>
+          </a:p>
+          <a:p>
+            <a:r>
+              <a:rPr lang="en-US" sz="1800">
+                <a:latin typeface="Calibri" panose="020F0502020204030204" pitchFamily="34" charset="0"/>
+              </a:rPr>
+              <a:t>Every step is logged and monitored in Google Cloud</a:t>
             </a:r>
           </a:p>
         </p:txBody>
@@ -5436,7 +5428,7 @@
     </p:spTree>
     <p:extLst>
       <p:ext uri="{BB962C8B-B14F-4D97-AF65-F5344CB8AC3E}">
-        <p14:creationId xmlns:p14="http://schemas.microsoft.com/office/powerpoint/2010/main" val="3059556973"/>
+        <p14:creationId xmlns:p14="http://schemas.microsoft.com/office/powerpoint/2010/main" val="3528867751"/>
       </p:ext>
     </p:extLst>
   </p:cSld>
@@ -5468,7 +5460,7 @@
           <p:cNvPr id="2" name="Title 1">
             <a:extLst>
               <a:ext uri="{FF2B5EF4-FFF2-40B4-BE49-F238E27FC236}">
-                <a16:creationId xmlns:a16="http://schemas.microsoft.com/office/drawing/2014/main" id="{A8F4907F-3C46-AF81-9FD8-291E7A77E9FC}"/>
+                <a16:creationId xmlns:a16="http://schemas.microsoft.com/office/drawing/2014/main" id="{EA000DBD-1325-1D11-FFB0-76F5A4645AE1}"/>
               </a:ext>
             </a:extLst>
           </p:cNvPr>
@@ -5498,7 +5490,7 @@
           <p:cNvPr id="3" name="Rectangle: Rounded Corners 2">
             <a:extLst>
               <a:ext uri="{FF2B5EF4-FFF2-40B4-BE49-F238E27FC236}">
-                <a16:creationId xmlns:a16="http://schemas.microsoft.com/office/drawing/2014/main" id="{B89C9E20-4D07-3896-7A37-B2C847087538}"/>
+                <a16:creationId xmlns:a16="http://schemas.microsoft.com/office/drawing/2014/main" id="{6E7067C4-25E0-15E5-A7D6-C3D22053718F}"/>
               </a:ext>
             </a:extLst>
           </p:cNvPr>
@@ -5555,12 +5547,15 @@
           </a:p>
           <a:p>
             <a:pPr algn="ctr"/>
-            <a:endParaRPr lang="en-US" sz="1100" b="1">
-              <a:solidFill>
-                <a:srgbClr val="1F3A5F"/>
-              </a:solidFill>
-              <a:latin typeface="Calibri" panose="020F0502020204030204" pitchFamily="34" charset="0"/>
-            </a:endParaRPr>
+            <a:r>
+              <a:rPr lang="en-US" sz="1100" b="1">
+                <a:solidFill>
+                  <a:srgbClr val="1F3A5F"/>
+                </a:solidFill>
+                <a:latin typeface="Calibri" panose="020F0502020204030204" pitchFamily="34" charset="0"/>
+              </a:rPr>
+              <a:t>Browser</a:t>
+            </a:r>
           </a:p>
         </p:txBody>
       </p:sp>
@@ -5569,7 +5564,7 @@
           <p:cNvPr id="4" name="Rectangle: Rounded Corners 3">
             <a:extLst>
               <a:ext uri="{FF2B5EF4-FFF2-40B4-BE49-F238E27FC236}">
-                <a16:creationId xmlns:a16="http://schemas.microsoft.com/office/drawing/2014/main" id="{D65264C1-02B1-6125-DA54-4AB33E126A04}"/>
+                <a16:creationId xmlns:a16="http://schemas.microsoft.com/office/drawing/2014/main" id="{B0C7447C-B28C-ED91-6859-FD7553678200}"/>
               </a:ext>
             </a:extLst>
           </p:cNvPr>
@@ -5621,7 +5616,7 @@
                 </a:solidFill>
                 <a:latin typeface="Calibri" panose="020F0502020204030204" pitchFamily="34" charset="0"/>
               </a:rPr>
-              <a:t>Next.js</a:t>
+              <a:t>Frontend</a:t>
             </a:r>
           </a:p>
           <a:p>
@@ -5633,7 +5628,7 @@
                 </a:solidFill>
                 <a:latin typeface="Calibri" panose="020F0502020204030204" pitchFamily="34" charset="0"/>
               </a:rPr>
-              <a:t>Frontend / Cloud Run</a:t>
+              <a:t>Next.js on Cloud Run</a:t>
             </a:r>
           </a:p>
         </p:txBody>
@@ -5643,7 +5638,7 @@
           <p:cNvPr id="5" name="Rectangle: Rounded Corners 4">
             <a:extLst>
               <a:ext uri="{FF2B5EF4-FFF2-40B4-BE49-F238E27FC236}">
-                <a16:creationId xmlns:a16="http://schemas.microsoft.com/office/drawing/2014/main" id="{73F930C6-EE54-4E91-E136-2CCBD5A1BF06}"/>
+                <a16:creationId xmlns:a16="http://schemas.microsoft.com/office/drawing/2014/main" id="{68A3CF10-786C-BB3E-DE94-D3DAB8C2D92B}"/>
               </a:ext>
             </a:extLst>
           </p:cNvPr>
@@ -5695,7 +5690,7 @@
                 </a:solidFill>
                 <a:latin typeface="Calibri" panose="020F0502020204030204" pitchFamily="34" charset="0"/>
               </a:rPr>
-              <a:t>Orchestrator</a:t>
+              <a:t>Backend</a:t>
             </a:r>
           </a:p>
           <a:p>
@@ -5707,7 +5702,7 @@
                 </a:solidFill>
                 <a:latin typeface="Calibri" panose="020F0502020204030204" pitchFamily="34" charset="0"/>
               </a:rPr>
-              <a:t>FastAPI / Cloud Run</a:t>
+              <a:t>FastAPI on Cloud Run</a:t>
             </a:r>
           </a:p>
         </p:txBody>
@@ -5717,7 +5712,7 @@
           <p:cNvPr id="6" name="Rectangle: Rounded Corners 5">
             <a:extLst>
               <a:ext uri="{FF2B5EF4-FFF2-40B4-BE49-F238E27FC236}">
-                <a16:creationId xmlns:a16="http://schemas.microsoft.com/office/drawing/2014/main" id="{503ACC94-1DAC-485A-DF6E-AAF53B6D7BF5}"/>
+                <a16:creationId xmlns:a16="http://schemas.microsoft.com/office/drawing/2014/main" id="{DE675D81-7009-C592-9737-03262BC4CB87}"/>
               </a:ext>
             </a:extLst>
           </p:cNvPr>
@@ -5769,7 +5764,7 @@
                 </a:solidFill>
                 <a:latin typeface="Calibri" panose="020F0502020204030204" pitchFamily="34" charset="0"/>
               </a:rPr>
-              <a:t>GCS</a:t>
+              <a:t>Documents</a:t>
             </a:r>
           </a:p>
           <a:p>
@@ -5781,7 +5776,7 @@
                 </a:solidFill>
                 <a:latin typeface="Calibri" panose="020F0502020204030204" pitchFamily="34" charset="0"/>
               </a:rPr>
-              <a:t>PDFs (signed URL)</a:t>
+              <a:t>Cloud Storage</a:t>
             </a:r>
           </a:p>
         </p:txBody>
@@ -5791,7 +5786,7 @@
           <p:cNvPr id="7" name="Rectangle: Rounded Corners 6">
             <a:extLst>
               <a:ext uri="{FF2B5EF4-FFF2-40B4-BE49-F238E27FC236}">
-                <a16:creationId xmlns:a16="http://schemas.microsoft.com/office/drawing/2014/main" id="{C55725B8-A8CB-4A57-041D-71ED927CC504}"/>
+                <a16:creationId xmlns:a16="http://schemas.microsoft.com/office/drawing/2014/main" id="{079E90C0-4D68-535B-5CFC-C745710AC187}"/>
               </a:ext>
             </a:extLst>
           </p:cNvPr>
@@ -5843,7 +5838,7 @@
                 </a:solidFill>
                 <a:latin typeface="Calibri" panose="020F0502020204030204" pitchFamily="34" charset="0"/>
               </a:rPr>
-              <a:t>Firestore</a:t>
+              <a:t>Results</a:t>
             </a:r>
           </a:p>
           <a:p>
@@ -5855,7 +5850,7 @@
                 </a:solidFill>
                 <a:latin typeface="Calibri" panose="020F0502020204030204" pitchFamily="34" charset="0"/>
               </a:rPr>
-              <a:t>Findings + audit</a:t>
+              <a:t>Firestore</a:t>
             </a:r>
           </a:p>
         </p:txBody>
@@ -5865,7 +5860,7 @@
           <p:cNvPr id="8" name="Straight Arrow Connector 7">
             <a:extLst>
               <a:ext uri="{FF2B5EF4-FFF2-40B4-BE49-F238E27FC236}">
-                <a16:creationId xmlns:a16="http://schemas.microsoft.com/office/drawing/2014/main" id="{F6BED2DC-2B89-05A2-6613-C5B4656817A1}"/>
+                <a16:creationId xmlns:a16="http://schemas.microsoft.com/office/drawing/2014/main" id="{2273594E-22A1-FF2D-5F4F-1FE1F9728925}"/>
               </a:ext>
             </a:extLst>
           </p:cNvPr>
@@ -5907,7 +5902,7 @@
           <p:cNvPr id="9" name="Straight Arrow Connector 8">
             <a:extLst>
               <a:ext uri="{FF2B5EF4-FFF2-40B4-BE49-F238E27FC236}">
-                <a16:creationId xmlns:a16="http://schemas.microsoft.com/office/drawing/2014/main" id="{9BD5118F-D376-28B7-27FF-73CC1F031350}"/>
+                <a16:creationId xmlns:a16="http://schemas.microsoft.com/office/drawing/2014/main" id="{A0E800C4-BDCC-0306-2EFC-F27390E48B31}"/>
               </a:ext>
             </a:extLst>
           </p:cNvPr>
@@ -5949,7 +5944,7 @@
           <p:cNvPr id="10" name="Straight Arrow Connector 9">
             <a:extLst>
               <a:ext uri="{FF2B5EF4-FFF2-40B4-BE49-F238E27FC236}">
-                <a16:creationId xmlns:a16="http://schemas.microsoft.com/office/drawing/2014/main" id="{C2603237-C7E7-0BD3-ADBA-0A00EBB80199}"/>
+                <a16:creationId xmlns:a16="http://schemas.microsoft.com/office/drawing/2014/main" id="{BDD165C0-ECDD-65B6-5F10-820921425FE2}"/>
               </a:ext>
             </a:extLst>
           </p:cNvPr>
@@ -5991,7 +5986,7 @@
           <p:cNvPr id="11" name="Straight Arrow Connector 10">
             <a:extLst>
               <a:ext uri="{FF2B5EF4-FFF2-40B4-BE49-F238E27FC236}">
-                <a16:creationId xmlns:a16="http://schemas.microsoft.com/office/drawing/2014/main" id="{1C611FDD-5319-E823-F116-9B4E65133932}"/>
+                <a16:creationId xmlns:a16="http://schemas.microsoft.com/office/drawing/2014/main" id="{AC310957-AB02-6DF4-4EEA-C812003A284E}"/>
               </a:ext>
             </a:extLst>
           </p:cNvPr>
@@ -6033,7 +6028,7 @@
           <p:cNvPr id="12" name="Straight Arrow Connector 11">
             <a:extLst>
               <a:ext uri="{FF2B5EF4-FFF2-40B4-BE49-F238E27FC236}">
-                <a16:creationId xmlns:a16="http://schemas.microsoft.com/office/drawing/2014/main" id="{A7F71E07-DB58-92E8-BCD6-B17C29842266}"/>
+                <a16:creationId xmlns:a16="http://schemas.microsoft.com/office/drawing/2014/main" id="{E773EF23-00BF-1C64-D9BF-1E36EBB9CDB9}"/>
               </a:ext>
             </a:extLst>
           </p:cNvPr>
@@ -6075,7 +6070,7 @@
           <p:cNvPr id="13" name="Rectangle: Rounded Corners 12">
             <a:extLst>
               <a:ext uri="{FF2B5EF4-FFF2-40B4-BE49-F238E27FC236}">
-                <a16:creationId xmlns:a16="http://schemas.microsoft.com/office/drawing/2014/main" id="{EB6AD73B-A9E0-437D-60E1-8602DD3777A3}"/>
+                <a16:creationId xmlns:a16="http://schemas.microsoft.com/office/drawing/2014/main" id="{85F2E8D6-A8EE-BF10-2C3F-8F59349D8F39}"/>
               </a:ext>
             </a:extLst>
           </p:cNvPr>
@@ -6149,7 +6144,7 @@
           <p:cNvPr id="14" name="Rectangle: Rounded Corners 13">
             <a:extLst>
               <a:ext uri="{FF2B5EF4-FFF2-40B4-BE49-F238E27FC236}">
-                <a16:creationId xmlns:a16="http://schemas.microsoft.com/office/drawing/2014/main" id="{F1292360-2995-0159-9F6E-76B662604D80}"/>
+                <a16:creationId xmlns:a16="http://schemas.microsoft.com/office/drawing/2014/main" id="{D2C2DB3F-1A44-0CAC-ED22-3905145B7BE9}"/>
               </a:ext>
             </a:extLst>
           </p:cNvPr>
@@ -6223,7 +6218,7 @@
           <p:cNvPr id="15" name="Rectangle: Rounded Corners 14">
             <a:extLst>
               <a:ext uri="{FF2B5EF4-FFF2-40B4-BE49-F238E27FC236}">
-                <a16:creationId xmlns:a16="http://schemas.microsoft.com/office/drawing/2014/main" id="{7D219D2D-36EF-9869-F98D-6CD76C47DCC3}"/>
+                <a16:creationId xmlns:a16="http://schemas.microsoft.com/office/drawing/2014/main" id="{1A277A21-9B74-254D-F648-CD7C1B8D526F}"/>
               </a:ext>
             </a:extLst>
           </p:cNvPr>
@@ -6297,7 +6292,7 @@
           <p:cNvPr id="16" name="Rectangle: Rounded Corners 15">
             <a:extLst>
               <a:ext uri="{FF2B5EF4-FFF2-40B4-BE49-F238E27FC236}">
-                <a16:creationId xmlns:a16="http://schemas.microsoft.com/office/drawing/2014/main" id="{9FC71164-E0C8-B153-A627-4328AF001712}"/>
+                <a16:creationId xmlns:a16="http://schemas.microsoft.com/office/drawing/2014/main" id="{EDA2943D-369C-7219-35A8-73771D957F14}"/>
               </a:ext>
             </a:extLst>
           </p:cNvPr>
@@ -6371,7 +6366,7 @@
           <p:cNvPr id="17" name="Straight Arrow Connector 16">
             <a:extLst>
               <a:ext uri="{FF2B5EF4-FFF2-40B4-BE49-F238E27FC236}">
-                <a16:creationId xmlns:a16="http://schemas.microsoft.com/office/drawing/2014/main" id="{074E1C21-CDEA-7717-29A1-E3BA0374A85C}"/>
+                <a16:creationId xmlns:a16="http://schemas.microsoft.com/office/drawing/2014/main" id="{4EC4C490-5A75-899E-35C5-92A20CA591D2}"/>
               </a:ext>
             </a:extLst>
           </p:cNvPr>
@@ -6413,7 +6408,7 @@
           <p:cNvPr id="18" name="Rectangle: Rounded Corners 17">
             <a:extLst>
               <a:ext uri="{FF2B5EF4-FFF2-40B4-BE49-F238E27FC236}">
-                <a16:creationId xmlns:a16="http://schemas.microsoft.com/office/drawing/2014/main" id="{B5966B17-8B8F-CE38-7844-8B6A79D88C11}"/>
+                <a16:creationId xmlns:a16="http://schemas.microsoft.com/office/drawing/2014/main" id="{770FA9F0-3283-F6F4-5F78-B34C5B46C580}"/>
               </a:ext>
             </a:extLst>
           </p:cNvPr>
@@ -6465,7 +6460,7 @@
                 </a:solidFill>
                 <a:latin typeface="Calibri" panose="020F0502020204030204" pitchFamily="34" charset="0"/>
               </a:rPr>
-              <a:t>Consolidation + Severity Grading</a:t>
+              <a:t>Combine and grade findings</a:t>
             </a:r>
           </a:p>
           <a:p>
@@ -6477,7 +6472,7 @@
                 </a:solidFill>
                 <a:latin typeface="Calibri" panose="020F0502020204030204" pitchFamily="34" charset="0"/>
               </a:rPr>
-              <a:t>dedupe - combine related - grade low/medium/high/critical</a:t>
+              <a:t>deduplicate - severity: Low, Medium, High, Critical</a:t>
             </a:r>
           </a:p>
         </p:txBody>
@@ -6487,7 +6482,7 @@
           <p:cNvPr id="19" name="Straight Arrow Connector 18">
             <a:extLst>
               <a:ext uri="{FF2B5EF4-FFF2-40B4-BE49-F238E27FC236}">
-                <a16:creationId xmlns:a16="http://schemas.microsoft.com/office/drawing/2014/main" id="{362D9E72-68B8-25F8-DCBE-0912B4C6B9A1}"/>
+                <a16:creationId xmlns:a16="http://schemas.microsoft.com/office/drawing/2014/main" id="{09623FC3-58FC-21D9-13CB-512FF3F8D683}"/>
               </a:ext>
             </a:extLst>
           </p:cNvPr>
@@ -6529,7 +6524,7 @@
           <p:cNvPr id="20" name="Rectangle: Rounded Corners 19">
             <a:extLst>
               <a:ext uri="{FF2B5EF4-FFF2-40B4-BE49-F238E27FC236}">
-                <a16:creationId xmlns:a16="http://schemas.microsoft.com/office/drawing/2014/main" id="{6F2B666F-CE10-865F-C4D7-4A80EE30C76C}"/>
+                <a16:creationId xmlns:a16="http://schemas.microsoft.com/office/drawing/2014/main" id="{3C5EABC6-8997-527F-A1C9-7B2AB614D5D1}"/>
               </a:ext>
             </a:extLst>
           </p:cNvPr>
@@ -6581,7 +6576,7 @@
                 </a:solidFill>
                 <a:latin typeface="Calibri" panose="020F0502020204030204" pitchFamily="34" charset="0"/>
               </a:rPr>
-              <a:t>Final Report streamed to Frontend (SSE)</a:t>
+              <a:t>Final report streamed live to the user</a:t>
             </a:r>
           </a:p>
           <a:p>
@@ -6601,7 +6596,7 @@
     </p:spTree>
     <p:extLst>
       <p:ext uri="{BB962C8B-B14F-4D97-AF65-F5344CB8AC3E}">
-        <p14:creationId xmlns:p14="http://schemas.microsoft.com/office/powerpoint/2010/main" val="3985720046"/>
+        <p14:creationId xmlns:p14="http://schemas.microsoft.com/office/powerpoint/2010/main" val="795564527"/>
       </p:ext>
     </p:extLst>
   </p:cSld>
@@ -6633,7 +6628,7 @@
           <p:cNvPr id="2" name="Title 1">
             <a:extLst>
               <a:ext uri="{FF2B5EF4-FFF2-40B4-BE49-F238E27FC236}">
-                <a16:creationId xmlns:a16="http://schemas.microsoft.com/office/drawing/2014/main" id="{EC5F0E1C-8A6A-C68F-2655-3E3FF3BDFE8C}"/>
+                <a16:creationId xmlns:a16="http://schemas.microsoft.com/office/drawing/2014/main" id="{E81C650E-CF1D-C580-05D8-777DDFA5E126}"/>
               </a:ext>
             </a:extLst>
           </p:cNvPr>
@@ -6663,7 +6658,7 @@
           <p:cNvPr id="3" name="Text Placeholder 2">
             <a:extLst>
               <a:ext uri="{FF2B5EF4-FFF2-40B4-BE49-F238E27FC236}">
-                <a16:creationId xmlns:a16="http://schemas.microsoft.com/office/drawing/2014/main" id="{561AA307-163D-114F-6FC9-F45D22F6301E}"/>
+                <a16:creationId xmlns:a16="http://schemas.microsoft.com/office/drawing/2014/main" id="{A92DEB98-966B-7884-19F3-E3B35EE5334F}"/>
               </a:ext>
             </a:extLst>
           </p:cNvPr>
@@ -6677,7 +6672,7 @@
         <p:spPr/>
         <p:txBody>
           <a:bodyPr>
-            <a:normAutofit/>
+            <a:normAutofit lnSpcReduction="10000"/>
           </a:bodyPr>
           <a:lstStyle/>
           <a:p>
@@ -6685,7 +6680,7 @@
               <a:rPr lang="en-US" sz="1800">
                 <a:latin typeface="Calibri" panose="020F0502020204030204" pitchFamily="34" charset="0"/>
               </a:rPr>
-              <a:t>Orchestrator (controller): primary entry point - validates the bundle and coordinates the rest</a:t>
+              <a:t>One orchestrator coordinates everything - each agent has only one job</a:t>
             </a:r>
           </a:p>
           <a:p>
@@ -6693,7 +6688,7 @@
               <a:rPr lang="en-US" sz="1800">
                 <a:latin typeface="Calibri" panose="020F0502020204030204" pitchFamily="34" charset="0"/>
               </a:rPr>
-              <a:t>Fan-out: Parser first, then Legal + Fraud in parallel, then Report - progress streamed via SSE</a:t>
+              <a:t>Parser runs first; Legal and Fraud run in parallel; Report runs last</a:t>
             </a:r>
           </a:p>
           <a:p>
@@ -6701,7 +6696,7 @@
               <a:rPr lang="en-US" sz="1800">
                 <a:latin typeface="Calibri" panose="020F0502020204030204" pitchFamily="34" charset="0"/>
               </a:rPr>
-              <a:t>Each specialised Gemini agent has its own focused system prompt and JSON output schema</a:t>
+              <a:t>Every agent uses Gemini 2.5 Flash with its own focused prompt</a:t>
             </a:r>
           </a:p>
           <a:p>
@@ -6709,7 +6704,7 @@
               <a:rPr lang="en-US" sz="1800">
                 <a:latin typeface="Calibri" panose="020F0502020204030204" pitchFamily="34" charset="0"/>
               </a:rPr>
-              <a:t>Parser is multimodal (reads PDFs natively); the rest consume structured JSON</a:t>
+              <a:t>Agents talk to each other through a shared JSON schema</a:t>
             </a:r>
           </a:p>
           <a:p>
@@ -6717,7 +6712,7 @@
               <a:rPr lang="en-US" sz="1800">
                 <a:latin typeface="Calibri" panose="020F0502020204030204" pitchFamily="34" charset="0"/>
               </a:rPr>
-              <a:t>Stateless agents exchange JSON, allowing easy retry and parallelism</a:t>
+              <a:t>Parser reads the PDFs directly - no separate OCR step needed</a:t>
             </a:r>
           </a:p>
           <a:p>
@@ -6725,7 +6720,7 @@
               <a:rPr lang="en-US" sz="1800">
                 <a:latin typeface="Calibri" panose="020F0502020204030204" pitchFamily="34" charset="0"/>
               </a:rPr>
-              <a:t>In-process Python calls today (sub-second latency, lower cost)</a:t>
+              <a:t>Stateless design means any single agent can be retried without redoing the rest</a:t>
             </a:r>
           </a:p>
           <a:p>
@@ -6733,7 +6728,7 @@
               <a:rPr lang="en-US" sz="1800">
                 <a:latin typeface="Calibri" panose="020F0502020204030204" pitchFamily="34" charset="0"/>
               </a:rPr>
-              <a:t>Designed so any agent can be promoted to its own Cloud Run service via HTTP/JSON</a:t>
+              <a:t>Today they run together for speed and lower cost</a:t>
             </a:r>
           </a:p>
           <a:p>
@@ -6741,7 +6736,7 @@
               <a:rPr lang="en-US" sz="1800">
                 <a:latin typeface="Calibri" panose="020F0502020204030204" pitchFamily="34" charset="0"/>
               </a:rPr>
-              <a:t>A shared ExtractedData schema keeps contracts stable across agents</a:t>
+              <a:t>Any one of them can later be split into its own Cloud Run service if we need to scale it</a:t>
             </a:r>
           </a:p>
         </p:txBody>
@@ -6749,7 +6744,7 @@
     </p:spTree>
     <p:extLst>
       <p:ext uri="{BB962C8B-B14F-4D97-AF65-F5344CB8AC3E}">
-        <p14:creationId xmlns:p14="http://schemas.microsoft.com/office/powerpoint/2010/main" val="3720242863"/>
+        <p14:creationId xmlns:p14="http://schemas.microsoft.com/office/powerpoint/2010/main" val="2874459464"/>
       </p:ext>
     </p:extLst>
   </p:cSld>
@@ -6781,7 +6776,7 @@
           <p:cNvPr id="2" name="Title 1">
             <a:extLst>
               <a:ext uri="{FF2B5EF4-FFF2-40B4-BE49-F238E27FC236}">
-                <a16:creationId xmlns:a16="http://schemas.microsoft.com/office/drawing/2014/main" id="{356A7816-BF34-DCFC-D606-9A7392B39BE1}"/>
+                <a16:creationId xmlns:a16="http://schemas.microsoft.com/office/drawing/2014/main" id="{EAAC9771-4E41-97EC-7795-1C2CAD22457F}"/>
               </a:ext>
             </a:extLst>
           </p:cNvPr>
@@ -6811,7 +6806,7 @@
           <p:cNvPr id="3" name="Table 2">
             <a:extLst>
               <a:ext uri="{FF2B5EF4-FFF2-40B4-BE49-F238E27FC236}">
-                <a16:creationId xmlns:a16="http://schemas.microsoft.com/office/drawing/2014/main" id="{F5374C98-B451-4AA2-9657-FE2047DEE41D}"/>
+                <a16:creationId xmlns:a16="http://schemas.microsoft.com/office/drawing/2014/main" id="{0FB84DA3-4D6B-F44F-B641-81B118FF75E5}"/>
               </a:ext>
             </a:extLst>
           </p:cNvPr>
@@ -6821,7 +6816,7 @@
           <p:nvPr>
             <p:extLst>
               <p:ext uri="{D42A27DB-BD31-4B8C-83A1-F6EECF244321}">
-                <p14:modId xmlns:p14="http://schemas.microsoft.com/office/powerpoint/2010/main" val="1279002998"/>
+                <p14:modId xmlns:p14="http://schemas.microsoft.com/office/powerpoint/2010/main" val="1800138905"/>
               </p:ext>
             </p:extLst>
           </p:nvPr>
@@ -6840,21 +6835,21 @@
                 <a:gridCol w="2159000">
                   <a:extLst>
                     <a:ext uri="{9D8B030D-6E8A-4147-A177-3AD203B41FA5}">
-                      <a16:colId xmlns:a16="http://schemas.microsoft.com/office/drawing/2014/main" val="2795509212"/>
+                      <a16:colId xmlns:a16="http://schemas.microsoft.com/office/drawing/2014/main" val="1606083994"/>
                     </a:ext>
                   </a:extLst>
                 </a:gridCol>
                 <a:gridCol w="5969000">
                   <a:extLst>
                     <a:ext uri="{9D8B030D-6E8A-4147-A177-3AD203B41FA5}">
-                      <a16:colId xmlns:a16="http://schemas.microsoft.com/office/drawing/2014/main" val="3991510656"/>
+                      <a16:colId xmlns:a16="http://schemas.microsoft.com/office/drawing/2014/main" val="3413616763"/>
                     </a:ext>
                   </a:extLst>
                 </a:gridCol>
                 <a:gridCol w="3048000">
                   <a:extLst>
                     <a:ext uri="{9D8B030D-6E8A-4147-A177-3AD203B41FA5}">
-                      <a16:colId xmlns:a16="http://schemas.microsoft.com/office/drawing/2014/main" val="3779695251"/>
+                      <a16:colId xmlns:a16="http://schemas.microsoft.com/office/drawing/2014/main" val="2543403098"/>
                     </a:ext>
                   </a:extLst>
                 </a:gridCol>
@@ -6901,7 +6896,7 @@
                 </a:tc>
                 <a:extLst>
                   <a:ext uri="{0D108BD9-81ED-4DB2-BD59-A6C34878D82A}">
-                    <a16:rowId xmlns:a16="http://schemas.microsoft.com/office/drawing/2014/main" val="765493789"/>
+                    <a16:rowId xmlns:a16="http://schemas.microsoft.com/office/drawing/2014/main" val="2673849826"/>
                   </a:ext>
                 </a:extLst>
               </a:tr>
@@ -6926,7 +6921,7 @@
                     <a:p>
                       <a:r>
                         <a:rPr lang="en-US"/>
-                        <a:t>Receives the bundle, fans out parallel agent calls, streams progress, persists state.</a:t>
+                        <a:t>Takes the bundle, runs the agents, streams progress, saves results.</a:t>
                       </a:r>
                     </a:p>
                   </a:txBody>
@@ -6939,7 +6934,7 @@
                     <a:p>
                       <a:r>
                         <a:rPr lang="en-US"/>
-                        <a:t>FastAPI / Cloud Run + Firestore</a:t>
+                        <a:t>FastAPI on Cloud Run + Firestore</a:t>
                       </a:r>
                     </a:p>
                   </a:txBody>
@@ -6947,7 +6942,7 @@
                 </a:tc>
                 <a:extLst>
                   <a:ext uri="{0D108BD9-81ED-4DB2-BD59-A6C34878D82A}">
-                    <a16:rowId xmlns:a16="http://schemas.microsoft.com/office/drawing/2014/main" val="3239374324"/>
+                    <a16:rowId xmlns:a16="http://schemas.microsoft.com/office/drawing/2014/main" val="3490206408"/>
                   </a:ext>
                 </a:extLst>
               </a:tr>
@@ -6972,7 +6967,7 @@
                     <a:p>
                       <a:r>
                         <a:rPr lang="en-US"/>
-                        <a:t>Reads PDFs natively. Extracts parties, area, stamp duty, registration details, chain of title.</a:t>
+                        <a:t>Reads each PDF and pulls out parties, area, stamp duty, dates and registration details.</a:t>
                       </a:r>
                     </a:p>
                   </a:txBody>
@@ -6993,7 +6988,7 @@
                 </a:tc>
                 <a:extLst>
                   <a:ext uri="{0D108BD9-81ED-4DB2-BD59-A6C34878D82A}">
-                    <a16:rowId xmlns:a16="http://schemas.microsoft.com/office/drawing/2014/main" val="2634904952"/>
+                    <a16:rowId xmlns:a16="http://schemas.microsoft.com/office/drawing/2014/main" val="3380558906"/>
                   </a:ext>
                 </a:extLst>
               </a:tr>
@@ -7018,7 +7013,7 @@
                     <a:p>
                       <a:r>
                         <a:rPr lang="en-US"/>
-                        <a:t>Maps extracted data against Indian land law. Flags only concrete document-specific issues.</a:t>
+                        <a:t>Checks the documents against Indian land law and flags any non-compliance.</a:t>
                       </a:r>
                     </a:p>
                   </a:txBody>
@@ -7039,7 +7034,7 @@
                 </a:tc>
                 <a:extLst>
                   <a:ext uri="{0D108BD9-81ED-4DB2-BD59-A6C34878D82A}">
-                    <a16:rowId xmlns:a16="http://schemas.microsoft.com/office/drawing/2014/main" val="3063148662"/>
+                    <a16:rowId xmlns:a16="http://schemas.microsoft.com/office/drawing/2014/main" val="1231896642"/>
                   </a:ext>
                 </a:extLst>
               </a:tr>
@@ -7064,7 +7059,7 @@
                     <a:p>
                       <a:r>
                         <a:rPr lang="en-US"/>
-                        <a:t>Detects name mismatches, chain-of-title gaps, undervaluation. Consolidates related observations.</a:t>
+                        <a:t>Looks for red flags: name mismatches, broken ownership chain, missing signatures, undervaluation.</a:t>
                       </a:r>
                     </a:p>
                   </a:txBody>
@@ -7085,7 +7080,7 @@
                 </a:tc>
                 <a:extLst>
                   <a:ext uri="{0D108BD9-81ED-4DB2-BD59-A6C34878D82A}">
-                    <a16:rowId xmlns:a16="http://schemas.microsoft.com/office/drawing/2014/main" val="801786509"/>
+                    <a16:rowId xmlns:a16="http://schemas.microsoft.com/office/drawing/2014/main" val="1567642139"/>
                   </a:ext>
                 </a:extLst>
               </a:tr>
@@ -7110,7 +7105,7 @@
                     <a:p>
                       <a:r>
                         <a:rPr lang="en-US"/>
-                        <a:t>Synthesises findings into a lawyer-style summary, grades severity, and recommends next steps.</a:t>
+                        <a:t>Combines all findings into a short summary, grades severity, suggests next steps.</a:t>
                       </a:r>
                     </a:p>
                   </a:txBody>
@@ -7131,7 +7126,7 @@
                 </a:tc>
                 <a:extLst>
                   <a:ext uri="{0D108BD9-81ED-4DB2-BD59-A6C34878D82A}">
-                    <a16:rowId xmlns:a16="http://schemas.microsoft.com/office/drawing/2014/main" val="2919296804"/>
+                    <a16:rowId xmlns:a16="http://schemas.microsoft.com/office/drawing/2014/main" val="907606091"/>
                   </a:ext>
                 </a:extLst>
               </a:tr>
@@ -7142,7 +7137,7 @@
     </p:spTree>
     <p:extLst>
       <p:ext uri="{BB962C8B-B14F-4D97-AF65-F5344CB8AC3E}">
-        <p14:creationId xmlns:p14="http://schemas.microsoft.com/office/powerpoint/2010/main" val="103461054"/>
+        <p14:creationId xmlns:p14="http://schemas.microsoft.com/office/powerpoint/2010/main" val="3090997554"/>
       </p:ext>
     </p:extLst>
   </p:cSld>
@@ -7174,7 +7169,7 @@
           <p:cNvPr id="2" name="Title 1">
             <a:extLst>
               <a:ext uri="{FF2B5EF4-FFF2-40B4-BE49-F238E27FC236}">
-                <a16:creationId xmlns:a16="http://schemas.microsoft.com/office/drawing/2014/main" id="{EDA69C42-5090-F908-DF22-F73580CC5EA4}"/>
+                <a16:creationId xmlns:a16="http://schemas.microsoft.com/office/drawing/2014/main" id="{31CFF8AA-E0E1-8DBD-35ED-DB6446D4A488}"/>
               </a:ext>
             </a:extLst>
           </p:cNvPr>
@@ -7204,7 +7199,7 @@
           <p:cNvPr id="3" name="Text Placeholder 2">
             <a:extLst>
               <a:ext uri="{FF2B5EF4-FFF2-40B4-BE49-F238E27FC236}">
-                <a16:creationId xmlns:a16="http://schemas.microsoft.com/office/drawing/2014/main" id="{78222569-1269-DA4E-8065-B43F8C4B5C3F}"/>
+                <a16:creationId xmlns:a16="http://schemas.microsoft.com/office/drawing/2014/main" id="{12AC5EFC-DAEE-F4CF-500E-0D0165D6D959}"/>
               </a:ext>
             </a:extLst>
           </p:cNvPr>
@@ -7218,87 +7213,87 @@
         <p:spPr/>
         <p:txBody>
           <a:bodyPr>
-            <a:normAutofit fontScale="70000" lnSpcReduction="20000"/>
+            <a:normAutofit/>
           </a:bodyPr>
           <a:lstStyle/>
           <a:p>
             <a:r>
-              <a:rPr lang="en-US">
-                <a:latin typeface="Calibri" panose="020F0502020204030204" pitchFamily="34" charset="0"/>
-              </a:rPr>
-              <a:t>Frontend (Next.js): Dockerised, deployed to Cloud Run, CDN-cached static assets</a:t>
-            </a:r>
-          </a:p>
-          <a:p>
-            <a:r>
-              <a:rPr lang="en-US">
-                <a:latin typeface="Calibri" panose="020F0502020204030204" pitchFamily="34" charset="0"/>
-              </a:rPr>
-              <a:t>Backend (FastAPI): Dockerised, deployed to Cloud Run, auto-scales 0 -&gt; N, Gunicorn + Uvicorn workers</a:t>
-            </a:r>
-          </a:p>
-          <a:p>
-            <a:r>
-              <a:rPr lang="en-US">
-                <a:latin typeface="Calibri" panose="020F0502020204030204" pitchFamily="34" charset="0"/>
-              </a:rPr>
-              <a:t>CI/CD: GitHub push -&gt; Cloud Build -&gt; builds both images -&gt; Artifact Registry -&gt; deploys to Cloud Run</a:t>
-            </a:r>
-          </a:p>
-          <a:p>
-            <a:r>
-              <a:rPr lang="en-US">
-                <a:latin typeface="Calibri" panose="020F0502020204030204" pitchFamily="34" charset="0"/>
-              </a:rPr>
-              <a:t>Artifact Registry: stores backend + frontend Docker images, vulnerability scanning enabled</a:t>
-            </a:r>
-          </a:p>
-          <a:p>
-            <a:r>
-              <a:rPr lang="en-US">
-                <a:latin typeface="Calibri" panose="020F0502020204030204" pitchFamily="34" charset="0"/>
-              </a:rPr>
-              <a:t>Secret Manager: holds Gemini API keys and Firebase admin credentials; Cloud Run reads at startup</a:t>
-            </a:r>
-          </a:p>
-          <a:p>
-            <a:r>
-              <a:rPr lang="en-US">
-                <a:latin typeface="Calibri" panose="020F0502020204030204" pitchFamily="34" charset="0"/>
-              </a:rPr>
-              <a:t>Cloud Storage: bucket for uploaded documents, signed URLs with short TTL, lifecycle expiry</a:t>
-            </a:r>
-          </a:p>
-          <a:p>
-            <a:r>
-              <a:rPr lang="en-US">
-                <a:latin typeface="Calibri" panose="020F0502020204030204" pitchFamily="34" charset="0"/>
-              </a:rPr>
-              <a:t>Firestore: native-mode database, stores analysis records, findings, audit log</a:t>
-            </a:r>
-          </a:p>
-          <a:p>
-            <a:r>
-              <a:rPr lang="en-US">
-                <a:latin typeface="Calibri" panose="020F0502020204030204" pitchFamily="34" charset="0"/>
-              </a:rPr>
-              <a:t>IAM: dedicated service account per Cloud Run service, least-privilege on Firestore / GCS / Secret Manager</a:t>
-            </a:r>
-          </a:p>
-          <a:p>
-            <a:r>
-              <a:rPr lang="en-US">
-                <a:latin typeface="Calibri" panose="020F0502020204030204" pitchFamily="34" charset="0"/>
-              </a:rPr>
-              <a:t>Logging &amp; Monitoring: structured JSON logs, alerts on error rate and Gemini latency</a:t>
-            </a:r>
-          </a:p>
-          <a:p>
-            <a:r>
-              <a:rPr lang="en-US">
-                <a:latin typeface="Calibri" panose="020F0502020204030204" pitchFamily="34" charset="0"/>
-              </a:rPr>
-              <a:t>Firebase Auth: email/password and Google sign-in, ID tokens verified server-side per request</a:t>
+              <a:rPr lang="en-US" sz="1800">
+                <a:latin typeface="Calibri" panose="020F0502020204030204" pitchFamily="34" charset="0"/>
+              </a:rPr>
+              <a:t>Frontend and backend both run on Cloud Run as Docker containers</a:t>
+            </a:r>
+          </a:p>
+          <a:p>
+            <a:r>
+              <a:rPr lang="en-US" sz="1800">
+                <a:latin typeface="Calibri" panose="020F0502020204030204" pitchFamily="34" charset="0"/>
+              </a:rPr>
+              <a:t>Push to GitHub triggers Cloud Build to build the images and deploy automatically</a:t>
+            </a:r>
+          </a:p>
+          <a:p>
+            <a:r>
+              <a:rPr lang="en-US" sz="1800">
+                <a:latin typeface="Calibri" panose="020F0502020204030204" pitchFamily="34" charset="0"/>
+              </a:rPr>
+              <a:t>Docker images are stored in Artifact Registry with vulnerability scanning on</a:t>
+            </a:r>
+          </a:p>
+          <a:p>
+            <a:r>
+              <a:rPr lang="en-US" sz="1800">
+                <a:latin typeface="Calibri" panose="020F0502020204030204" pitchFamily="34" charset="0"/>
+              </a:rPr>
+              <a:t>Secrets (API keys, Firebase credentials) live in Secret Manager and are loaded at startup</a:t>
+            </a:r>
+          </a:p>
+          <a:p>
+            <a:r>
+              <a:rPr lang="en-US" sz="1800">
+                <a:latin typeface="Calibri" panose="020F0502020204030204" pitchFamily="34" charset="0"/>
+              </a:rPr>
+              <a:t>Uploaded documents go to Cloud Storage with short-lived signed URLs</a:t>
+            </a:r>
+          </a:p>
+          <a:p>
+            <a:r>
+              <a:rPr lang="en-US" sz="1800">
+                <a:latin typeface="Calibri" panose="020F0502020204030204" pitchFamily="34" charset="0"/>
+              </a:rPr>
+              <a:t>Analysis results and the audit log are stored in Firestore</a:t>
+            </a:r>
+          </a:p>
+          <a:p>
+            <a:r>
+              <a:rPr lang="en-US" sz="1800">
+                <a:latin typeface="Calibri" panose="020F0502020204030204" pitchFamily="34" charset="0"/>
+              </a:rPr>
+              <a:t>Cloud Run auto-scales from zero, so we only pay for what we use</a:t>
+            </a:r>
+          </a:p>
+          <a:p>
+            <a:r>
+              <a:rPr lang="en-US" sz="1800">
+                <a:latin typeface="Calibri" panose="020F0502020204030204" pitchFamily="34" charset="0"/>
+              </a:rPr>
+              <a:t>Each service has its own least-privilege IAM service account</a:t>
+            </a:r>
+          </a:p>
+          <a:p>
+            <a:r>
+              <a:rPr lang="en-US" sz="1800">
+                <a:latin typeface="Calibri" panose="020F0502020204030204" pitchFamily="34" charset="0"/>
+              </a:rPr>
+              <a:t>Logs and metrics are centralised in Cloud Logging and Monitoring with alerts</a:t>
+            </a:r>
+          </a:p>
+          <a:p>
+            <a:r>
+              <a:rPr lang="en-US" sz="1800">
+                <a:latin typeface="Calibri" panose="020F0502020204030204" pitchFamily="34" charset="0"/>
+              </a:rPr>
+              <a:t>Every request is protected by Firebase Authentication</a:t>
             </a:r>
           </a:p>
         </p:txBody>
@@ -7306,7 +7301,7 @@
     </p:spTree>
     <p:extLst>
       <p:ext uri="{BB962C8B-B14F-4D97-AF65-F5344CB8AC3E}">
-        <p14:creationId xmlns:p14="http://schemas.microsoft.com/office/powerpoint/2010/main" val="3107219128"/>
+        <p14:creationId xmlns:p14="http://schemas.microsoft.com/office/powerpoint/2010/main" val="759315424"/>
       </p:ext>
     </p:extLst>
   </p:cSld>

</xml_diff>